<commit_message>
Rebuild G7 Science (30) and G8 Science (24) PPTs with rich educational content
Each PPT now has 8-10 slides including:
- Title slide with grade badge
- Learning objectives
- 2-3 content slides with real teaching material
- Two-column comparisons where relevant
- Key vocabulary with Chinese translations
- Worked examples with step-by-step solutions (Science/Maths)
- Think-Pair-Share discussion prompts
- Check Your Understanding (4 Q&A)
- Key Takeaways summary
- End slide

Average file size: ~155KB (was ~157KB but with 2x more useful content)
Slide engine: ppt-engine.js with 10 slide type functions
</commit_message>
<xml_diff>
--- a/static/ppts/G6_Sci_T1_Full_Revision.pptx
+++ b/static/ppts/G6_Sci_T1_Full_Revision.pptx
@@ -14,12 +14,13 @@
     <p:sldId id="262" r:id="rId8"/>
     <p:sldId id="263" r:id="rId9"/>
     <p:sldId id="264" r:id="rId10"/>
+    <p:sldId id="265" r:id="rId11"/>
   </p:sldIdLst>
   <p:notesMasterIdLst>
-    <p:notesMasterId r:id="rId11"/>
+    <p:notesMasterId r:id="rId12"/>
   </p:notesMasterIdLst>
-  <p:sldSz cx="9144000" cy="5143500"/>
-  <p:notesSz cx="5143500" cy="9144000"/>
+  <p:sldSz cx="12192000" cy="6858000"/>
+  <p:notesSz cx="6858000" cy="12192000"/>
   <p:defaultTextStyle>
     <a:lvl1pPr marL="0" algn="l" defTabSz="914400" rtl="0" eaLnBrk="1" latinLnBrk="0" hangingPunct="1">
       <a:defRPr sz="1800" kern="1200">
@@ -534,6 +535,94 @@
             <a:fld id="{F7021451-1387-4CA6-816F-3879F97B5CBC}" type="slidenum">
               <a:rPr lang="en-US"/>
               <a:t>1</a:t>
+            </a:fld>
+            <a:endParaRPr lang="en-US"/>
+          </a:p>
+        </p:txBody>
+      </p:sp>
+    </p:spTree>
+    <p:extLst>
+      <p:ext uri="{BB962C8B-B14F-4D97-AF65-F5344CB8AC3E}">
+        <p14:creationId xmlns:p14="http://schemas.microsoft.com/office/powerpoint/2010/main" val="1024086991"/>
+      </p:ext>
+    </p:extLst>
+  </p:cSld>
+  <p:clrMapOvr>
+    <a:masterClrMapping/>
+  </p:clrMapOvr>
+</p:notes>
+</file>
+
+<file path=ppt/notesSlides/notesSlide10.xml><?xml version="1.0" encoding="utf-8"?>
+<p:notes xmlns:a="http://schemas.openxmlformats.org/drawingml/2006/main" xmlns:r="http://schemas.openxmlformats.org/officeDocument/2006/relationships" xmlns:p="http://schemas.openxmlformats.org/presentationml/2006/main">
+  <p:cSld>
+    <p:spTree>
+      <p:nvGrpSpPr>
+        <p:cNvPr id="1" name=""/>
+        <p:cNvGrpSpPr/>
+        <p:nvPr/>
+      </p:nvGrpSpPr>
+      <p:grpSpPr>
+        <a:xfrm>
+          <a:off x="0" y="0"/>
+          <a:ext cx="0" cy="0"/>
+          <a:chOff x="0" y="0"/>
+          <a:chExt cx="0" cy="0"/>
+        </a:xfrm>
+      </p:grpSpPr>
+      <p:sp>
+        <p:nvSpPr>
+          <p:cNvPr id="2" name="Slide Image Placeholder 1"/>
+          <p:cNvSpPr>
+            <a:spLocks noGrp="1" noRot="1" noChangeAspect="1"/>
+          </p:cNvSpPr>
+          <p:nvPr>
+            <p:ph type="sldImg"/>
+          </p:nvPr>
+        </p:nvSpPr>
+        <p:spPr/>
+      </p:sp>
+      <p:sp>
+        <p:nvSpPr>
+          <p:cNvPr id="3" name="Notes Placeholder 2"/>
+          <p:cNvSpPr>
+            <a:spLocks noGrp="1"/>
+          </p:cNvSpPr>
+          <p:nvPr>
+            <p:ph type="body" idx="1"/>
+          </p:nvPr>
+        </p:nvSpPr>
+        <p:spPr/>
+        <p:txBody>
+          <a:bodyPr/>
+          <a:lstStyle/>
+          <a:p>
+            <a:r>
+              <a:rPr lang="en-US" dirty="0"/>
+              <a:t/>
+            </a:r>
+            <a:endParaRPr lang="en-US" dirty="0"/>
+          </a:p>
+        </p:txBody>
+      </p:sp>
+      <p:sp>
+        <p:nvSpPr>
+          <p:cNvPr id="4" name="Slide Number Placeholder 3"/>
+          <p:cNvSpPr>
+            <a:spLocks noGrp="1"/>
+          </p:cNvSpPr>
+          <p:nvPr>
+            <p:ph type="sldNum" sz="quarter" idx="10"/>
+          </p:nvPr>
+        </p:nvSpPr>
+        <p:spPr/>
+        <p:txBody>
+          <a:bodyPr/>
+          <a:lstStyle/>
+          <a:p>
+            <a:fld id="{F7021451-1387-4CA6-816F-3879F97B5CBC}" type="slidenum">
+              <a:rPr lang="en-US"/>
+              <a:t>10</a:t>
             </a:fld>
             <a:endParaRPr lang="en-US"/>
           </a:p>
@@ -1566,6 +1655,13 @@
 <file path=ppt/slides/slide1.xml><?xml version="1.0" encoding="utf-8"?>
 <p:sld xmlns:a="http://schemas.openxmlformats.org/drawingml/2006/main" xmlns:r="http://schemas.openxmlformats.org/officeDocument/2006/relationships" xmlns:p="http://schemas.openxmlformats.org/presentationml/2006/main">
   <p:cSld name="Slide 1">
+    <p:bg>
+      <p:bgPr>
+        <a:solidFill>
+          <a:srgbClr val="2A9D8F"/>
+        </a:solidFill>
+      </p:bgPr>
+    </p:bg>
     <p:spTree>
       <p:nvGrpSpPr>
         <p:cNvPr id="1" name=""/>
@@ -1588,55 +1684,15 @@
         </p:nvSpPr>
         <p:spPr>
           <a:xfrm>
-            <a:off x="0" y="0"/>
-            <a:ext cx="9144000" cy="5143500"/>
-          </a:xfrm>
-          <a:prstGeom prst="rect">
+            <a:off x="7772400" y="-914400"/>
+            <a:ext cx="3657600" cy="3657600"/>
+          </a:xfrm>
+          <a:prstGeom prst="ellipse">
             <a:avLst/>
           </a:prstGeom>
           <a:solidFill>
-            <a:srgbClr val="1B2A4A"/>
-          </a:solidFill>
-          <a:ln/>
-        </p:spPr>
-      </p:sp>
-      <p:sp>
-        <p:nvSpPr>
-          <p:cNvPr id="3" name="Shape 1"/>
-          <p:cNvSpPr/>
-          <p:nvPr/>
-        </p:nvSpPr>
-        <p:spPr>
-          <a:xfrm>
-            <a:off x="0" y="4777740"/>
-            <a:ext cx="9144000" cy="365760"/>
-          </a:xfrm>
-          <a:prstGeom prst="rect">
-            <a:avLst/>
-          </a:prstGeom>
-          <a:solidFill>
-            <a:srgbClr val="2A9D8F"/>
-          </a:solidFill>
-          <a:ln/>
-        </p:spPr>
-      </p:sp>
-      <p:sp>
-        <p:nvSpPr>
-          <p:cNvPr id="4" name="Shape 2"/>
-          <p:cNvSpPr/>
-          <p:nvPr/>
-        </p:nvSpPr>
-        <p:spPr>
-          <a:xfrm>
-            <a:off x="6858000" y="-1371600"/>
-            <a:ext cx="4572000" cy="4572000"/>
-          </a:xfrm>
-          <a:prstGeom prst="ellipse">
-            <a:avLst/>
-          </a:prstGeom>
-          <a:solidFill>
-            <a:srgbClr val="2A9D8F">
-              <a:alpha val="12000"/>
+            <a:srgbClr val="FFFFFF">
+              <a:alpha val="8000"/>
             </a:srgbClr>
           </a:solidFill>
           <a:ln/>
@@ -1644,14 +1700,14 @@
       </p:sp>
       <p:sp>
         <p:nvSpPr>
-          <p:cNvPr id="5" name="Text 3"/>
+          <p:cNvPr id="3" name="Text 1"/>
           <p:cNvSpPr/>
           <p:nvPr/>
         </p:nvSpPr>
         <p:spPr>
           <a:xfrm>
-            <a:off x="731520" y="914400"/>
-            <a:ext cx="7680960" cy="457200"/>
+            <a:off x="731520" y="548640"/>
+            <a:ext cx="7315200" cy="365760"/>
           </a:xfrm>
           <a:prstGeom prst="rect">
             <a:avLst/>
@@ -1667,30 +1723,30 @@
               <a:buNone/>
             </a:pPr>
             <a:r>
-              <a:rPr lang="en-US" sz="1300" b="1" spc="500" kern="0" dirty="0">
+              <a:rPr lang="en-US" sz="1100" b="1" dirty="0">
                 <a:solidFill>
-                  <a:srgbClr val="2A9D8F"/>
+                  <a:srgbClr val="F2D68A"/>
                 </a:solidFill>
-                <a:latin typeface="Calibri" pitchFamily="34" charset="0"/>
-                <a:ea typeface="Calibri" pitchFamily="34" charset="-122"/>
-                <a:cs typeface="Calibri" pitchFamily="34" charset="-120"/>
+                <a:latin typeface="Arial" pitchFamily="34" charset="0"/>
+                <a:ea typeface="Arial" pitchFamily="34" charset="-122"/>
+                <a:cs typeface="Arial" pitchFamily="34" charset="-120"/>
               </a:rPr>
               <a:t>GRADE 6 SCIENCE</a:t>
             </a:r>
-            <a:endParaRPr lang="en-US" sz="1300" dirty="0"/>
-          </a:p>
-        </p:txBody>
-      </p:sp>
-      <p:sp>
-        <p:nvSpPr>
-          <p:cNvPr id="6" name="Text 4"/>
+            <a:endParaRPr lang="en-US" sz="1100" dirty="0"/>
+          </a:p>
+        </p:txBody>
+      </p:sp>
+      <p:sp>
+        <p:nvSpPr>
+          <p:cNvPr id="4" name="Text 2"/>
           <p:cNvSpPr/>
           <p:nvPr/>
         </p:nvSpPr>
         <p:spPr>
           <a:xfrm>
-            <a:off x="731520" y="1463040"/>
-            <a:ext cx="6858000" cy="1645920"/>
+            <a:off x="731520" y="1371600"/>
+            <a:ext cx="9144000" cy="1645920"/>
           </a:xfrm>
           <a:prstGeom prst="rect">
             <a:avLst/>
@@ -1699,14 +1755,17 @@
           <a:ln/>
         </p:spPr>
         <p:txBody>
-          <a:bodyPr wrap="square" rtlCol="0" anchor="t"/>
+          <a:bodyPr wrap="square" rtlCol="0" anchor="ctr"/>
           <a:lstStyle/>
           <a:p>
             <a:pPr indent="0" marL="0">
+              <a:lnSpc>
+                <a:spcPct val="110000"/>
+              </a:lnSpc>
               <a:buNone/>
             </a:pPr>
             <a:r>
-              <a:rPr lang="en-US" sz="3800" b="1" dirty="0">
+              <a:rPr lang="en-US" sz="3600" b="1" dirty="0">
                 <a:solidFill>
                   <a:srgbClr val="FFFFFF"/>
                 </a:solidFill>
@@ -1714,39 +1773,63 @@
                 <a:ea typeface="Georgia" pitchFamily="34" charset="-122"/>
                 <a:cs typeface="Georgia" pitchFamily="34" charset="-120"/>
               </a:rPr>
-              <a:t>Scientific Skills</a:t>
-            </a:r>
-            <a:endParaRPr lang="en-US" sz="3800" dirty="0"/>
-          </a:p>
+              <a:t>Full Revision — Scientific Skills</a:t>
+            </a:r>
+            <a:endParaRPr lang="en-US" sz="3600" dirty="0"/>
+          </a:p>
+        </p:txBody>
+      </p:sp>
+      <p:sp>
+        <p:nvSpPr>
+          <p:cNvPr id="5" name="Text 3"/>
+          <p:cNvSpPr/>
+          <p:nvPr/>
+        </p:nvSpPr>
+        <p:spPr>
+          <a:xfrm>
+            <a:off x="731520" y="3200400"/>
+            <a:ext cx="7315200" cy="548640"/>
+          </a:xfrm>
+          <a:prstGeom prst="rect">
+            <a:avLst/>
+          </a:prstGeom>
+          <a:noFill/>
+          <a:ln/>
+        </p:spPr>
+        <p:txBody>
+          <a:bodyPr wrap="square" rtlCol="0" anchor="ctr"/>
+          <a:lstStyle/>
           <a:p>
             <a:pPr indent="0" marL="0">
               <a:buNone/>
             </a:pPr>
             <a:r>
-              <a:rPr lang="en-US" sz="3800" b="1" dirty="0">
+              <a:rPr lang="en-US" sz="1600" dirty="0">
                 <a:solidFill>
-                  <a:srgbClr val="FFFFFF"/>
+                  <a:srgbClr val="FFFFFF">
+                    <a:alpha val="65000"/>
+                  </a:srgbClr>
                 </a:solidFill>
-                <a:latin typeface="Georgia" pitchFamily="34" charset="0"/>
-                <a:ea typeface="Georgia" pitchFamily="34" charset="-122"/>
-                <a:cs typeface="Georgia" pitchFamily="34" charset="-120"/>
+                <a:latin typeface="Arial" pitchFamily="34" charset="0"/>
+                <a:ea typeface="Arial" pitchFamily="34" charset="-122"/>
+                <a:cs typeface="Arial" pitchFamily="34" charset="-120"/>
               </a:rPr>
-              <a:t>Full Revision</a:t>
-            </a:r>
-            <a:endParaRPr lang="en-US" sz="3800" dirty="0"/>
-          </a:p>
-        </p:txBody>
-      </p:sp>
-      <p:sp>
-        <p:nvSpPr>
-          <p:cNvPr id="7" name="Text 5"/>
+              <a:t>Review all topics from Term 1</a:t>
+            </a:r>
+            <a:endParaRPr lang="en-US" sz="1600" dirty="0"/>
+          </a:p>
+        </p:txBody>
+      </p:sp>
+      <p:sp>
+        <p:nvSpPr>
+          <p:cNvPr id="6" name="Text 4"/>
           <p:cNvSpPr/>
           <p:nvPr/>
         </p:nvSpPr>
         <p:spPr>
           <a:xfrm>
-            <a:off x="731520" y="3200400"/>
-            <a:ext cx="6400800" cy="548640"/>
+            <a:off x="731520" y="4389120"/>
+            <a:ext cx="2743200" cy="320040"/>
           </a:xfrm>
           <a:prstGeom prst="rect">
             <a:avLst/>
@@ -1762,56 +1845,19 @@
               <a:buNone/>
             </a:pPr>
             <a:r>
-              <a:rPr lang="en-US" sz="1600" i="1" dirty="0">
+              <a:rPr lang="en-US" sz="1000" dirty="0">
                 <a:solidFill>
-                  <a:srgbClr val="9B9690"/>
+                  <a:srgbClr val="FFFFFF">
+                    <a:alpha val="40000"/>
+                  </a:srgbClr>
                 </a:solidFill>
-                <a:latin typeface="Calibri" pitchFamily="34" charset="0"/>
-                <a:ea typeface="Calibri" pitchFamily="34" charset="-122"/>
-                <a:cs typeface="Calibri" pitchFamily="34" charset="-120"/>
-              </a:rPr>
-              <a:t>Everything you need for the test</a:t>
-            </a:r>
-            <a:endParaRPr lang="en-US" sz="1600" dirty="0"/>
-          </a:p>
-        </p:txBody>
-      </p:sp>
-      <p:sp>
-        <p:nvSpPr>
-          <p:cNvPr id="8" name="Text 6"/>
-          <p:cNvSpPr/>
-          <p:nvPr/>
-        </p:nvSpPr>
-        <p:spPr>
-          <a:xfrm>
-            <a:off x="731520" y="4297680"/>
-            <a:ext cx="2743200" cy="365760"/>
-          </a:xfrm>
-          <a:prstGeom prst="rect">
-            <a:avLst/>
-          </a:prstGeom>
-          <a:noFill/>
-          <a:ln/>
-        </p:spPr>
-        <p:txBody>
-          <a:bodyPr wrap="square" rtlCol="0" anchor="ctr"/>
-          <a:lstStyle/>
-          <a:p>
-            <a:pPr indent="0" marL="0">
-              <a:buNone/>
-            </a:pPr>
-            <a:r>
-              <a:rPr lang="en-US" sz="1100" dirty="0">
-                <a:solidFill>
-                  <a:srgbClr val="9B9690"/>
-                </a:solidFill>
-                <a:latin typeface="Calibri" pitchFamily="34" charset="0"/>
-                <a:ea typeface="Calibri" pitchFamily="34" charset="-122"/>
-                <a:cs typeface="Calibri" pitchFamily="34" charset="-120"/>
+                <a:latin typeface="Arial" pitchFamily="34" charset="0"/>
+                <a:ea typeface="Arial" pitchFamily="34" charset="-122"/>
+                <a:cs typeface="Arial" pitchFamily="34" charset="-120"/>
               </a:rPr>
               <a:t>mrzocchi.com</a:t>
             </a:r>
-            <a:endParaRPr lang="en-US" sz="1100" dirty="0"/>
+            <a:endParaRPr lang="en-US" sz="1000" dirty="0"/>
           </a:p>
         </p:txBody>
       </p:sp>
@@ -1823,9 +1869,16 @@
 </p:sld>
 </file>
 
-<file path=ppt/slides/slide2.xml><?xml version="1.0" encoding="utf-8"?>
+<file path=ppt/slides/slide10.xml><?xml version="1.0" encoding="utf-8"?>
 <p:sld xmlns:a="http://schemas.openxmlformats.org/drawingml/2006/main" xmlns:r="http://schemas.openxmlformats.org/officeDocument/2006/relationships" xmlns:p="http://schemas.openxmlformats.org/presentationml/2006/main">
-  <p:cSld name="Slide 2">
+  <p:cSld name="Slide 10">
+    <p:bg>
+      <p:bgPr>
+        <a:solidFill>
+          <a:srgbClr val="111D35"/>
+        </a:solidFill>
+      </p:bgPr>
+    </p:bg>
     <p:spTree>
       <p:nvGrpSpPr>
         <p:cNvPr id="1" name=""/>
@@ -1842,54 +1895,14 @@
       </p:grpSpPr>
       <p:sp>
         <p:nvSpPr>
-          <p:cNvPr id="2" name="Shape 0"/>
+          <p:cNvPr id="2" name="Text 0"/>
           <p:cNvSpPr/>
           <p:nvPr/>
         </p:nvSpPr>
         <p:spPr>
           <a:xfrm>
-            <a:off x="0" y="0"/>
-            <a:ext cx="9144000" cy="5143500"/>
-          </a:xfrm>
-          <a:prstGeom prst="rect">
-            <a:avLst/>
-          </a:prstGeom>
-          <a:solidFill>
-            <a:srgbClr val="1B2A4A"/>
-          </a:solidFill>
-          <a:ln/>
-        </p:spPr>
-      </p:sp>
-      <p:sp>
-        <p:nvSpPr>
-          <p:cNvPr id="3" name="Shape 1"/>
-          <p:cNvSpPr/>
-          <p:nvPr/>
-        </p:nvSpPr>
-        <p:spPr>
-          <a:xfrm>
-            <a:off x="731520" y="1828800"/>
-            <a:ext cx="73152" cy="1463040"/>
-          </a:xfrm>
-          <a:prstGeom prst="rect">
-            <a:avLst/>
-          </a:prstGeom>
-          <a:solidFill>
-            <a:srgbClr val="2A9D8F"/>
-          </a:solidFill>
-          <a:ln/>
-        </p:spPr>
-      </p:sp>
-      <p:sp>
-        <p:nvSpPr>
-          <p:cNvPr id="4" name="Text 2"/>
-          <p:cNvSpPr/>
-          <p:nvPr/>
-        </p:nvSpPr>
-        <p:spPr>
-          <a:xfrm>
-            <a:off x="1097280" y="1463040"/>
-            <a:ext cx="1097280" cy="1097280"/>
+            <a:off x="731520" y="1371600"/>
+            <a:ext cx="9144000" cy="914400"/>
           </a:xfrm>
           <a:prstGeom prst="rect">
             <a:avLst/>
@@ -1901,34 +1914,187 @@
           <a:bodyPr wrap="square" rtlCol="0" anchor="ctr"/>
           <a:lstStyle/>
           <a:p>
-            <a:pPr algn="l" indent="0" marL="0">
+            <a:pPr indent="0" marL="0">
               <a:buNone/>
             </a:pPr>
             <a:r>
-              <a:rPr lang="en-US" sz="4800" b="1" dirty="0">
+              <a:rPr lang="en-US" sz="3200" b="1" dirty="0">
                 <a:solidFill>
-                  <a:srgbClr val="2A9D8F"/>
+                  <a:srgbClr val="FFFFFF"/>
                 </a:solidFill>
                 <a:latin typeface="Georgia" pitchFamily="34" charset="0"/>
                 <a:ea typeface="Georgia" pitchFamily="34" charset="-122"/>
                 <a:cs typeface="Georgia" pitchFamily="34" charset="-120"/>
               </a:rPr>
-              <a:t>1</a:t>
-            </a:r>
-            <a:endParaRPr lang="en-US" sz="4800" dirty="0"/>
-          </a:p>
-        </p:txBody>
-      </p:sp>
-      <p:sp>
-        <p:nvSpPr>
-          <p:cNvPr id="5" name="Text 3"/>
+              <a:t>Review &amp; Practise</a:t>
+            </a:r>
+            <a:endParaRPr lang="en-US" sz="3200" dirty="0"/>
+          </a:p>
+        </p:txBody>
+      </p:sp>
+      <p:sp>
+        <p:nvSpPr>
+          <p:cNvPr id="3" name="Text 1"/>
           <p:cNvSpPr/>
           <p:nvPr/>
         </p:nvSpPr>
         <p:spPr>
           <a:xfrm>
-            <a:off x="2194560" y="1920240"/>
-            <a:ext cx="5943600" cy="1097280"/>
+            <a:off x="731520" y="2377440"/>
+            <a:ext cx="7315200" cy="548640"/>
+          </a:xfrm>
+          <a:prstGeom prst="rect">
+            <a:avLst/>
+          </a:prstGeom>
+          <a:noFill/>
+          <a:ln/>
+        </p:spPr>
+        <p:txBody>
+          <a:bodyPr wrap="square" rtlCol="0" anchor="ctr"/>
+          <a:lstStyle/>
+          <a:p>
+            <a:pPr indent="0" marL="0">
+              <a:buNone/>
+            </a:pPr>
+            <a:r>
+              <a:rPr lang="en-US" sz="1500" dirty="0">
+                <a:solidFill>
+                  <a:srgbClr val="FFFFFF">
+                    <a:alpha val="60000"/>
+                  </a:srgbClr>
+                </a:solidFill>
+                <a:latin typeface="Arial" pitchFamily="34" charset="0"/>
+                <a:ea typeface="Arial" pitchFamily="34" charset="-122"/>
+                <a:cs typeface="Arial" pitchFamily="34" charset="-120"/>
+              </a:rPr>
+              <a:t>Use the Self-Quiz, Review Games, and Practice Builder to test yourself.</a:t>
+            </a:r>
+            <a:endParaRPr lang="en-US" sz="1500" dirty="0"/>
+          </a:p>
+        </p:txBody>
+      </p:sp>
+      <p:sp>
+        <p:nvSpPr>
+          <p:cNvPr id="4" name="Text 2"/>
+          <p:cNvSpPr/>
+          <p:nvPr/>
+        </p:nvSpPr>
+        <p:spPr>
+          <a:xfrm>
+            <a:off x="731520" y="3291840"/>
+            <a:ext cx="3657600" cy="457200"/>
+          </a:xfrm>
+          <a:prstGeom prst="rect">
+            <a:avLst/>
+          </a:prstGeom>
+          <a:noFill/>
+          <a:ln/>
+        </p:spPr>
+        <p:txBody>
+          <a:bodyPr wrap="square" rtlCol="0" anchor="ctr"/>
+          <a:lstStyle/>
+          <a:p>
+            <a:pPr indent="0" marL="0">
+              <a:buNone/>
+            </a:pPr>
+            <a:r>
+              <a:rPr lang="en-US" sz="1800" b="1" dirty="0">
+                <a:solidFill>
+                  <a:srgbClr val="E9C46A"/>
+                </a:solidFill>
+                <a:latin typeface="Georgia" pitchFamily="34" charset="0"/>
+                <a:ea typeface="Georgia" pitchFamily="34" charset="-122"/>
+                <a:cs typeface="Georgia" pitchFamily="34" charset="-120"/>
+              </a:rPr>
+              <a:t>mrzocchi.com</a:t>
+            </a:r>
+            <a:endParaRPr lang="en-US" sz="1800" dirty="0"/>
+          </a:p>
+        </p:txBody>
+      </p:sp>
+    </p:spTree>
+  </p:cSld>
+  <p:clrMapOvr>
+    <a:masterClrMapping/>
+  </p:clrMapOvr>
+</p:sld>
+</file>
+
+<file path=ppt/slides/slide2.xml><?xml version="1.0" encoding="utf-8"?>
+<p:sld xmlns:a="http://schemas.openxmlformats.org/drawingml/2006/main" xmlns:r="http://schemas.openxmlformats.org/officeDocument/2006/relationships" xmlns:p="http://schemas.openxmlformats.org/presentationml/2006/main">
+  <p:cSld name="Slide 2">
+    <p:bg>
+      <p:bgPr>
+        <a:solidFill>
+          <a:srgbClr val="111D35"/>
+        </a:solidFill>
+      </p:bgPr>
+    </p:bg>
+    <p:spTree>
+      <p:nvGrpSpPr>
+        <p:cNvPr id="1" name=""/>
+        <p:cNvGrpSpPr/>
+        <p:nvPr/>
+      </p:nvGrpSpPr>
+      <p:grpSpPr>
+        <a:xfrm>
+          <a:off x="0" y="0"/>
+          <a:ext cx="0" cy="0"/>
+          <a:chOff x="0" y="0"/>
+          <a:chExt cx="0" cy="0"/>
+        </a:xfrm>
+      </p:grpSpPr>
+      <p:sp>
+        <p:nvSpPr>
+          <p:cNvPr id="2" name="Text 0"/>
+          <p:cNvSpPr/>
+          <p:nvPr/>
+        </p:nvSpPr>
+        <p:spPr>
+          <a:xfrm>
+            <a:off x="731520" y="731520"/>
+            <a:ext cx="2286000" cy="1828800"/>
+          </a:xfrm>
+          <a:prstGeom prst="rect">
+            <a:avLst/>
+          </a:prstGeom>
+          <a:noFill/>
+          <a:ln/>
+        </p:spPr>
+        <p:txBody>
+          <a:bodyPr wrap="square" rtlCol="0" anchor="ctr"/>
+          <a:lstStyle/>
+          <a:p>
+            <a:pPr indent="0" marL="0">
+              <a:buNone/>
+            </a:pPr>
+            <a:r>
+              <a:rPr lang="en-US" sz="7200" b="1" dirty="0">
+                <a:solidFill>
+                  <a:srgbClr val="2A9D8F">
+                    <a:alpha val="80000"/>
+                  </a:srgbClr>
+                </a:solidFill>
+                <a:latin typeface="Georgia" pitchFamily="34" charset="0"/>
+                <a:ea typeface="Georgia" pitchFamily="34" charset="-122"/>
+                <a:cs typeface="Georgia" pitchFamily="34" charset="-120"/>
+              </a:rPr>
+              <a:t>01</a:t>
+            </a:r>
+            <a:endParaRPr lang="en-US" sz="7200" dirty="0"/>
+          </a:p>
+        </p:txBody>
+      </p:sp>
+      <p:sp>
+        <p:nvSpPr>
+          <p:cNvPr id="3" name="Text 1"/>
+          <p:cNvSpPr/>
+          <p:nvPr/>
+        </p:nvSpPr>
+        <p:spPr>
+          <a:xfrm>
+            <a:off x="731520" y="1828800"/>
+            <a:ext cx="9144000" cy="1097280"/>
           </a:xfrm>
           <a:prstGeom prst="rect">
             <a:avLst/>
@@ -1955,6 +2121,47 @@
               <a:t>Lab Safety</a:t>
             </a:r>
             <a:endParaRPr lang="en-US" sz="3200" dirty="0"/>
+          </a:p>
+        </p:txBody>
+      </p:sp>
+      <p:sp>
+        <p:nvSpPr>
+          <p:cNvPr id="4" name="Text 2"/>
+          <p:cNvSpPr/>
+          <p:nvPr/>
+        </p:nvSpPr>
+        <p:spPr>
+          <a:xfrm>
+            <a:off x="731520" y="3017520"/>
+            <a:ext cx="7315200" cy="457200"/>
+          </a:xfrm>
+          <a:prstGeom prst="rect">
+            <a:avLst/>
+          </a:prstGeom>
+          <a:noFill/>
+          <a:ln/>
+        </p:spPr>
+        <p:txBody>
+          <a:bodyPr wrap="square" rtlCol="0" anchor="ctr"/>
+          <a:lstStyle/>
+          <a:p>
+            <a:pPr indent="0" marL="0">
+              <a:buNone/>
+            </a:pPr>
+            <a:r>
+              <a:rPr lang="en-US" sz="1400" dirty="0">
+                <a:solidFill>
+                  <a:srgbClr val="FFFFFF">
+                    <a:alpha val="60000"/>
+                  </a:srgbClr>
+                </a:solidFill>
+                <a:latin typeface="Arial" pitchFamily="34" charset="0"/>
+                <a:ea typeface="Arial" pitchFamily="34" charset="-122"/>
+                <a:cs typeface="Arial" pitchFamily="34" charset="-120"/>
+              </a:rPr>
+              <a:t>Key rules and hazard symbols</a:t>
+            </a:r>
+            <a:endParaRPr lang="en-US" sz="1400" dirty="0"/>
           </a:p>
         </p:txBody>
       </p:sp>
@@ -1999,47 +2206,7 @@
         <p:spPr>
           <a:xfrm>
             <a:off x="0" y="0"/>
-            <a:ext cx="9144000" cy="822960"/>
-          </a:xfrm>
-          <a:prstGeom prst="rect">
-            <a:avLst/>
-          </a:prstGeom>
-          <a:solidFill>
-            <a:srgbClr val="FFFFFF"/>
-          </a:solidFill>
-          <a:ln/>
-        </p:spPr>
-      </p:sp>
-      <p:sp>
-        <p:nvSpPr>
-          <p:cNvPr id="3" name="Shape 1"/>
-          <p:cNvSpPr/>
-          <p:nvPr/>
-        </p:nvSpPr>
-        <p:spPr>
-          <a:xfrm>
-            <a:off x="0" y="804672"/>
-            <a:ext cx="9144000" cy="27432"/>
-          </a:xfrm>
-          <a:prstGeom prst="rect">
-            <a:avLst/>
-          </a:prstGeom>
-          <a:solidFill>
-            <a:srgbClr val="E5E2DC"/>
-          </a:solidFill>
-          <a:ln/>
-        </p:spPr>
-      </p:sp>
-      <p:sp>
-        <p:nvSpPr>
-          <p:cNvPr id="4" name="Shape 2"/>
-          <p:cNvSpPr/>
-          <p:nvPr/>
-        </p:nvSpPr>
-        <p:spPr>
-          <a:xfrm>
-            <a:off x="548640" y="201168"/>
-            <a:ext cx="54864" cy="420624"/>
+            <a:ext cx="73152" cy="5148072"/>
           </a:xfrm>
           <a:prstGeom prst="rect">
             <a:avLst/>
@@ -2052,14 +2219,14 @@
       </p:sp>
       <p:sp>
         <p:nvSpPr>
-          <p:cNvPr id="5" name="Text 3"/>
+          <p:cNvPr id="3" name="Text 1"/>
           <p:cNvSpPr/>
           <p:nvPr/>
         </p:nvSpPr>
         <p:spPr>
           <a:xfrm>
-            <a:off x="777240" y="137160"/>
-            <a:ext cx="7772400" cy="548640"/>
+            <a:off x="548640" y="274320"/>
+            <a:ext cx="9144000" cy="640080"/>
           </a:xfrm>
           <a:prstGeom prst="rect">
             <a:avLst/>
@@ -2068,14 +2235,14 @@
           <a:ln/>
         </p:spPr>
         <p:txBody>
-          <a:bodyPr wrap="square" lIns="0" tIns="0" rIns="0" bIns="0" rtlCol="0" anchor="ctr"/>
+          <a:bodyPr wrap="square" rtlCol="0" anchor="ctr"/>
           <a:lstStyle/>
           <a:p>
             <a:pPr indent="0" marL="0">
               <a:buNone/>
             </a:pPr>
             <a:r>
-              <a:rPr lang="en-US" sz="2000" b="1" dirty="0">
+              <a:rPr lang="en-US" sz="2400" b="1" dirty="0">
                 <a:solidFill>
                   <a:srgbClr val="1B2A4A"/>
                 </a:solidFill>
@@ -2083,22 +2250,42 @@
                 <a:ea typeface="Georgia" pitchFamily="34" charset="-122"/>
                 <a:cs typeface="Georgia" pitchFamily="34" charset="-120"/>
               </a:rPr>
-              <a:t>Safety Review</a:t>
-            </a:r>
-            <a:endParaRPr lang="en-US" sz="2000" dirty="0"/>
-          </a:p>
-        </p:txBody>
-      </p:sp>
-      <p:sp>
-        <p:nvSpPr>
-          <p:cNvPr id="6" name="Text 4"/>
+              <a:t>Lab Safety Recap</a:t>
+            </a:r>
+            <a:endParaRPr lang="en-US" sz="2400" dirty="0"/>
+          </a:p>
+        </p:txBody>
+      </p:sp>
+      <p:sp>
+        <p:nvSpPr>
+          <p:cNvPr id="4" name="Shape 2"/>
           <p:cNvSpPr/>
           <p:nvPr/>
         </p:nvSpPr>
         <p:spPr>
           <a:xfrm>
-            <a:off x="731520" y="1051560"/>
-            <a:ext cx="7680960" cy="3108960"/>
+            <a:off x="548640" y="960120"/>
+            <a:ext cx="2286000" cy="36576"/>
+          </a:xfrm>
+          <a:prstGeom prst="rect">
+            <a:avLst/>
+          </a:prstGeom>
+          <a:solidFill>
+            <a:srgbClr val="2A9D8F"/>
+          </a:solidFill>
+          <a:ln/>
+        </p:spPr>
+      </p:sp>
+      <p:sp>
+        <p:nvSpPr>
+          <p:cNvPr id="5" name="Text 3"/>
+          <p:cNvSpPr/>
+          <p:nvPr/>
+        </p:nvSpPr>
+        <p:spPr>
+          <a:xfrm>
+            <a:off x="548640" y="1188720"/>
+            <a:ext cx="10058400" cy="3474720"/>
           </a:xfrm>
           <a:prstGeom prst="rect">
             <a:avLst/>
@@ -2110,107 +2297,90 @@
           <a:bodyPr wrap="square" rtlCol="0" anchor="t"/>
           <a:lstStyle/>
           <a:p>
-            <a:pPr marL="342900" indent="-342900">
+            <a:pPr>
+              <a:lnSpc>
+                <a:spcPct val="150000"/>
+              </a:lnSpc>
               <a:spcAft>
-                <a:spcPts val="800"/>
+                <a:spcPts val="600"/>
               </a:spcAft>
-              <a:buSzPct val="100000"/>
-              <a:buChar char="•"/>
             </a:pPr>
             <a:r>
               <a:rPr lang="en-US" sz="1500" dirty="0">
                 <a:solidFill>
                   <a:srgbClr val="3D3A36"/>
                 </a:solidFill>
-                <a:latin typeface="Calibri" pitchFamily="34" charset="0"/>
-                <a:ea typeface="Calibri" pitchFamily="34" charset="-122"/>
-                <a:cs typeface="Calibri" pitchFamily="34" charset="-120"/>
+                <a:latin typeface="Arial" pitchFamily="34" charset="0"/>
+                <a:ea typeface="Arial" pitchFamily="34" charset="-122"/>
+                <a:cs typeface="Arial" pitchFamily="34" charset="-120"/>
               </a:rPr>
-              <a:t>Know your hazard symbols: flammable, corrosive, toxic, irritant, oxidising.</a:t>
+              <a:t>Always wear goggles. Tie back hair. No eating or drinking.</a:t>
             </a:r>
             <a:endParaRPr lang="en-US" sz="1500" dirty="0"/>
           </a:p>
           <a:p>
-            <a:pPr marL="342900" indent="-342900">
+            <a:pPr>
+              <a:lnSpc>
+                <a:spcPct val="150000"/>
+              </a:lnSpc>
               <a:spcAft>
-                <a:spcPts val="800"/>
+                <a:spcPts val="600"/>
               </a:spcAft>
-              <a:buSzPct val="100000"/>
-              <a:buChar char="•"/>
             </a:pPr>
             <a:r>
               <a:rPr lang="en-US" sz="1500" dirty="0">
                 <a:solidFill>
                   <a:srgbClr val="3D3A36"/>
                 </a:solidFill>
-                <a:latin typeface="Calibri" pitchFamily="34" charset="0"/>
-                <a:ea typeface="Calibri" pitchFamily="34" charset="-122"/>
-                <a:cs typeface="Calibri" pitchFamily="34" charset="-120"/>
+                <a:latin typeface="Arial" pitchFamily="34" charset="0"/>
+                <a:ea typeface="Arial" pitchFamily="34" charset="-122"/>
+                <a:cs typeface="Arial" pitchFamily="34" charset="-120"/>
               </a:rPr>
-              <a:t>Always wear appropriate PPE: goggles, gloves, lab coat.</a:t>
+              <a:t>Know hazard symbols: flammable, toxic, corrosive, irritant.</a:t>
             </a:r>
             <a:endParaRPr lang="en-US" sz="1500" dirty="0"/>
           </a:p>
           <a:p>
-            <a:pPr marL="342900" indent="-342900">
+            <a:pPr>
+              <a:lnSpc>
+                <a:spcPct val="150000"/>
+              </a:lnSpc>
               <a:spcAft>
-                <a:spcPts val="800"/>
+                <a:spcPts val="600"/>
               </a:spcAft>
-              <a:buSzPct val="100000"/>
-              <a:buChar char="•"/>
             </a:pPr>
             <a:r>
               <a:rPr lang="en-US" sz="1500" dirty="0">
                 <a:solidFill>
                   <a:srgbClr val="3D3A36"/>
                 </a:solidFill>
-                <a:latin typeface="Calibri" pitchFamily="34" charset="0"/>
-                <a:ea typeface="Calibri" pitchFamily="34" charset="-122"/>
-                <a:cs typeface="Calibri" pitchFamily="34" charset="-120"/>
+                <a:latin typeface="Arial" pitchFamily="34" charset="0"/>
+                <a:ea typeface="Arial" pitchFamily="34" charset="-122"/>
+                <a:cs typeface="Arial" pitchFamily="34" charset="-120"/>
               </a:rPr>
-              <a:t>A HAZARD is something that CAN cause harm. A RISK is the CHANCE it WILL.</a:t>
+              <a:t>Bunsen burner: yellow = safety flame, blue = heating flame.</a:t>
             </a:r>
             <a:endParaRPr lang="en-US" sz="1500" dirty="0"/>
           </a:p>
           <a:p>
-            <a:pPr marL="342900" indent="-342900">
+            <a:pPr>
+              <a:lnSpc>
+                <a:spcPct val="150000"/>
+              </a:lnSpc>
               <a:spcAft>
-                <a:spcPts val="800"/>
+                <a:spcPts val="600"/>
               </a:spcAft>
-              <a:buSzPct val="100000"/>
-              <a:buChar char="•"/>
             </a:pPr>
             <a:r>
               <a:rPr lang="en-US" sz="1500" dirty="0">
                 <a:solidFill>
                   <a:srgbClr val="3D3A36"/>
                 </a:solidFill>
-                <a:latin typeface="Calibri" pitchFamily="34" charset="0"/>
-                <a:ea typeface="Calibri" pitchFamily="34" charset="-122"/>
-                <a:cs typeface="Calibri" pitchFamily="34" charset="-120"/>
+                <a:latin typeface="Arial" pitchFamily="34" charset="0"/>
+                <a:ea typeface="Arial" pitchFamily="34" charset="-122"/>
+                <a:cs typeface="Arial" pitchFamily="34" charset="-120"/>
               </a:rPr>
-              <a:t>Emergency: TELL YOUR TEACHER first, then follow first aid steps.</a:t>
-            </a:r>
-            <a:endParaRPr lang="en-US" sz="1500" dirty="0"/>
-          </a:p>
-          <a:p>
-            <a:pPr marL="342900" indent="-342900">
-              <a:spcAft>
-                <a:spcPts val="800"/>
-              </a:spcAft>
-              <a:buSzPct val="100000"/>
-              <a:buChar char="•"/>
-            </a:pPr>
-            <a:r>
-              <a:rPr lang="en-US" sz="1500" dirty="0">
-                <a:solidFill>
-                  <a:srgbClr val="3D3A36"/>
-                </a:solidFill>
-                <a:latin typeface="Calibri" pitchFamily="34" charset="0"/>
-                <a:ea typeface="Calibri" pitchFamily="34" charset="-122"/>
-                <a:cs typeface="Calibri" pitchFamily="34" charset="-120"/>
-              </a:rPr>
-              <a:t>Never eat, drink, run, or play in the laboratory.</a:t>
+              <a:t>Report all spills and injuries to your teacher immediately.</a:t>
             </a:r>
             <a:endParaRPr lang="en-US" sz="1500" dirty="0"/>
           </a:p>
@@ -2227,6 +2397,13 @@
 <file path=ppt/slides/slide4.xml><?xml version="1.0" encoding="utf-8"?>
 <p:sld xmlns:a="http://schemas.openxmlformats.org/drawingml/2006/main" xmlns:r="http://schemas.openxmlformats.org/officeDocument/2006/relationships" xmlns:p="http://schemas.openxmlformats.org/presentationml/2006/main">
   <p:cSld name="Slide 4">
+    <p:bg>
+      <p:bgPr>
+        <a:solidFill>
+          <a:srgbClr val="111D35"/>
+        </a:solidFill>
+      </p:bgPr>
+    </p:bg>
     <p:spTree>
       <p:nvGrpSpPr>
         <p:cNvPr id="1" name=""/>
@@ -2243,54 +2420,14 @@
       </p:grpSpPr>
       <p:sp>
         <p:nvSpPr>
-          <p:cNvPr id="2" name="Shape 0"/>
+          <p:cNvPr id="2" name="Text 0"/>
           <p:cNvSpPr/>
           <p:nvPr/>
         </p:nvSpPr>
         <p:spPr>
           <a:xfrm>
-            <a:off x="0" y="0"/>
-            <a:ext cx="9144000" cy="5143500"/>
-          </a:xfrm>
-          <a:prstGeom prst="rect">
-            <a:avLst/>
-          </a:prstGeom>
-          <a:solidFill>
-            <a:srgbClr val="1B2A4A"/>
-          </a:solidFill>
-          <a:ln/>
-        </p:spPr>
-      </p:sp>
-      <p:sp>
-        <p:nvSpPr>
-          <p:cNvPr id="3" name="Shape 1"/>
-          <p:cNvSpPr/>
-          <p:nvPr/>
-        </p:nvSpPr>
-        <p:spPr>
-          <a:xfrm>
-            <a:off x="731520" y="1828800"/>
-            <a:ext cx="73152" cy="1463040"/>
-          </a:xfrm>
-          <a:prstGeom prst="rect">
-            <a:avLst/>
-          </a:prstGeom>
-          <a:solidFill>
-            <a:srgbClr val="2A9D8F"/>
-          </a:solidFill>
-          <a:ln/>
-        </p:spPr>
-      </p:sp>
-      <p:sp>
-        <p:nvSpPr>
-          <p:cNvPr id="4" name="Text 2"/>
-          <p:cNvSpPr/>
-          <p:nvPr/>
-        </p:nvSpPr>
-        <p:spPr>
-          <a:xfrm>
-            <a:off x="1097280" y="1463040"/>
-            <a:ext cx="1097280" cy="1097280"/>
+            <a:off x="731520" y="731520"/>
+            <a:ext cx="2286000" cy="1828800"/>
           </a:xfrm>
           <a:prstGeom prst="rect">
             <a:avLst/>
@@ -2302,34 +2439,36 @@
           <a:bodyPr wrap="square" rtlCol="0" anchor="ctr"/>
           <a:lstStyle/>
           <a:p>
-            <a:pPr algn="l" indent="0" marL="0">
+            <a:pPr indent="0" marL="0">
               <a:buNone/>
             </a:pPr>
             <a:r>
-              <a:rPr lang="en-US" sz="4800" b="1" dirty="0">
+              <a:rPr lang="en-US" sz="7200" b="1" dirty="0">
                 <a:solidFill>
-                  <a:srgbClr val="2A9D8F"/>
+                  <a:srgbClr val="2A9D8F">
+                    <a:alpha val="80000"/>
+                  </a:srgbClr>
                 </a:solidFill>
                 <a:latin typeface="Georgia" pitchFamily="34" charset="0"/>
                 <a:ea typeface="Georgia" pitchFamily="34" charset="-122"/>
                 <a:cs typeface="Georgia" pitchFamily="34" charset="-120"/>
               </a:rPr>
-              <a:t>2</a:t>
-            </a:r>
-            <a:endParaRPr lang="en-US" sz="4800" dirty="0"/>
-          </a:p>
-        </p:txBody>
-      </p:sp>
-      <p:sp>
-        <p:nvSpPr>
-          <p:cNvPr id="5" name="Text 3"/>
+              <a:t>02</a:t>
+            </a:r>
+            <a:endParaRPr lang="en-US" sz="7200" dirty="0"/>
+          </a:p>
+        </p:txBody>
+      </p:sp>
+      <p:sp>
+        <p:nvSpPr>
+          <p:cNvPr id="3" name="Text 1"/>
           <p:cNvSpPr/>
           <p:nvPr/>
         </p:nvSpPr>
         <p:spPr>
           <a:xfrm>
-            <a:off x="2194560" y="1920240"/>
-            <a:ext cx="5943600" cy="1097280"/>
+            <a:off x="731520" y="1828800"/>
+            <a:ext cx="9144000" cy="1097280"/>
           </a:xfrm>
           <a:prstGeom prst="rect">
             <a:avLst/>
@@ -2356,6 +2495,47 @@
               <a:t>Scientific Method</a:t>
             </a:r>
             <a:endParaRPr lang="en-US" sz="3200" dirty="0"/>
+          </a:p>
+        </p:txBody>
+      </p:sp>
+      <p:sp>
+        <p:nvSpPr>
+          <p:cNvPr id="4" name="Text 2"/>
+          <p:cNvSpPr/>
+          <p:nvPr/>
+        </p:nvSpPr>
+        <p:spPr>
+          <a:xfrm>
+            <a:off x="731520" y="3017520"/>
+            <a:ext cx="7315200" cy="457200"/>
+          </a:xfrm>
+          <a:prstGeom prst="rect">
+            <a:avLst/>
+          </a:prstGeom>
+          <a:noFill/>
+          <a:ln/>
+        </p:spPr>
+        <p:txBody>
+          <a:bodyPr wrap="square" rtlCol="0" anchor="ctr"/>
+          <a:lstStyle/>
+          <a:p>
+            <a:pPr indent="0" marL="0">
+              <a:buNone/>
+            </a:pPr>
+            <a:r>
+              <a:rPr lang="en-US" sz="1400" dirty="0">
+                <a:solidFill>
+                  <a:srgbClr val="FFFFFF">
+                    <a:alpha val="60000"/>
+                  </a:srgbClr>
+                </a:solidFill>
+                <a:latin typeface="Arial" pitchFamily="34" charset="0"/>
+                <a:ea typeface="Arial" pitchFamily="34" charset="-122"/>
+                <a:cs typeface="Arial" pitchFamily="34" charset="-120"/>
+              </a:rPr>
+              <a:t>The steps of investigation</a:t>
+            </a:r>
+            <a:endParaRPr lang="en-US" sz="1400" dirty="0"/>
           </a:p>
         </p:txBody>
       </p:sp>
@@ -2400,47 +2580,7 @@
         <p:spPr>
           <a:xfrm>
             <a:off x="0" y="0"/>
-            <a:ext cx="9144000" cy="822960"/>
-          </a:xfrm>
-          <a:prstGeom prst="rect">
-            <a:avLst/>
-          </a:prstGeom>
-          <a:solidFill>
-            <a:srgbClr val="FFFFFF"/>
-          </a:solidFill>
-          <a:ln/>
-        </p:spPr>
-      </p:sp>
-      <p:sp>
-        <p:nvSpPr>
-          <p:cNvPr id="3" name="Shape 1"/>
-          <p:cNvSpPr/>
-          <p:nvPr/>
-        </p:nvSpPr>
-        <p:spPr>
-          <a:xfrm>
-            <a:off x="0" y="804672"/>
-            <a:ext cx="9144000" cy="27432"/>
-          </a:xfrm>
-          <a:prstGeom prst="rect">
-            <a:avLst/>
-          </a:prstGeom>
-          <a:solidFill>
-            <a:srgbClr val="E5E2DC"/>
-          </a:solidFill>
-          <a:ln/>
-        </p:spPr>
-      </p:sp>
-      <p:sp>
-        <p:nvSpPr>
-          <p:cNvPr id="4" name="Shape 2"/>
-          <p:cNvSpPr/>
-          <p:nvPr/>
-        </p:nvSpPr>
-        <p:spPr>
-          <a:xfrm>
-            <a:off x="548640" y="201168"/>
-            <a:ext cx="54864" cy="420624"/>
+            <a:ext cx="73152" cy="5148072"/>
           </a:xfrm>
           <a:prstGeom prst="rect">
             <a:avLst/>
@@ -2453,14 +2593,14 @@
       </p:sp>
       <p:sp>
         <p:nvSpPr>
-          <p:cNvPr id="5" name="Text 3"/>
+          <p:cNvPr id="3" name="Text 1"/>
           <p:cNvSpPr/>
           <p:nvPr/>
         </p:nvSpPr>
         <p:spPr>
           <a:xfrm>
-            <a:off x="777240" y="137160"/>
-            <a:ext cx="7772400" cy="548640"/>
+            <a:off x="548640" y="274320"/>
+            <a:ext cx="9144000" cy="640080"/>
           </a:xfrm>
           <a:prstGeom prst="rect">
             <a:avLst/>
@@ -2469,14 +2609,14 @@
           <a:ln/>
         </p:spPr>
         <p:txBody>
-          <a:bodyPr wrap="square" lIns="0" tIns="0" rIns="0" bIns="0" rtlCol="0" anchor="ctr"/>
+          <a:bodyPr wrap="square" rtlCol="0" anchor="ctr"/>
           <a:lstStyle/>
           <a:p>
             <a:pPr indent="0" marL="0">
               <a:buNone/>
             </a:pPr>
             <a:r>
-              <a:rPr lang="en-US" sz="2000" b="1" dirty="0">
+              <a:rPr lang="en-US" sz="2400" b="1" dirty="0">
                 <a:solidFill>
                   <a:srgbClr val="1B2A4A"/>
                 </a:solidFill>
@@ -2484,22 +2624,42 @@
                 <a:ea typeface="Georgia" pitchFamily="34" charset="-122"/>
                 <a:cs typeface="Georgia" pitchFamily="34" charset="-120"/>
               </a:rPr>
-              <a:t>Method &amp; Variables Review</a:t>
-            </a:r>
-            <a:endParaRPr lang="en-US" sz="2000" dirty="0"/>
-          </a:p>
-        </p:txBody>
-      </p:sp>
-      <p:sp>
-        <p:nvSpPr>
-          <p:cNvPr id="6" name="Text 4"/>
+              <a:t>Scientific Method Recap</a:t>
+            </a:r>
+            <a:endParaRPr lang="en-US" sz="2400" dirty="0"/>
+          </a:p>
+        </p:txBody>
+      </p:sp>
+      <p:sp>
+        <p:nvSpPr>
+          <p:cNvPr id="4" name="Shape 2"/>
           <p:cNvSpPr/>
           <p:nvPr/>
         </p:nvSpPr>
         <p:spPr>
           <a:xfrm>
-            <a:off x="731520" y="1051560"/>
-            <a:ext cx="7680960" cy="3108960"/>
+            <a:off x="548640" y="960120"/>
+            <a:ext cx="2286000" cy="36576"/>
+          </a:xfrm>
+          <a:prstGeom prst="rect">
+            <a:avLst/>
+          </a:prstGeom>
+          <a:solidFill>
+            <a:srgbClr val="2A9D8F"/>
+          </a:solidFill>
+          <a:ln/>
+        </p:spPr>
+      </p:sp>
+      <p:sp>
+        <p:nvSpPr>
+          <p:cNvPr id="5" name="Text 3"/>
+          <p:cNvSpPr/>
+          <p:nvPr/>
+        </p:nvSpPr>
+        <p:spPr>
+          <a:xfrm>
+            <a:off x="548640" y="1188720"/>
+            <a:ext cx="10058400" cy="3474720"/>
           </a:xfrm>
           <a:prstGeom prst="rect">
             <a:avLst/>
@@ -2511,107 +2671,90 @@
           <a:bodyPr wrap="square" rtlCol="0" anchor="t"/>
           <a:lstStyle/>
           <a:p>
-            <a:pPr marL="342900" indent="-342900">
+            <a:pPr>
+              <a:lnSpc>
+                <a:spcPct val="150000"/>
+              </a:lnSpc>
               <a:spcAft>
-                <a:spcPts val="800"/>
+                <a:spcPts val="600"/>
               </a:spcAft>
-              <a:buSzPct val="100000"/>
-              <a:buChar char="•"/>
             </a:pPr>
             <a:r>
               <a:rPr lang="en-US" sz="1500" dirty="0">
                 <a:solidFill>
                   <a:srgbClr val="3D3A36"/>
                 </a:solidFill>
-                <a:latin typeface="Calibri" pitchFamily="34" charset="0"/>
-                <a:ea typeface="Calibri" pitchFamily="34" charset="-122"/>
-                <a:cs typeface="Calibri" pitchFamily="34" charset="-120"/>
+                <a:latin typeface="Arial" pitchFamily="34" charset="0"/>
+                <a:ea typeface="Arial" pitchFamily="34" charset="-122"/>
+                <a:cs typeface="Arial" pitchFamily="34" charset="-120"/>
               </a:rPr>
-              <a:t>Steps: Question → Research → Hypothesis → Experiment → Data → Analysis → Conclusion.</a:t>
+              <a:t>Question → Research → Hypothesis → Experiment → Data → Analyse → Conclude → Evaluate.</a:t>
             </a:r>
             <a:endParaRPr lang="en-US" sz="1500" dirty="0"/>
           </a:p>
           <a:p>
-            <a:pPr marL="342900" indent="-342900">
+            <a:pPr>
+              <a:lnSpc>
+                <a:spcPct val="150000"/>
+              </a:lnSpc>
               <a:spcAft>
-                <a:spcPts val="800"/>
+                <a:spcPts val="600"/>
               </a:spcAft>
-              <a:buSzPct val="100000"/>
-              <a:buChar char="•"/>
             </a:pPr>
             <a:r>
               <a:rPr lang="en-US" sz="1500" dirty="0">
                 <a:solidFill>
                   <a:srgbClr val="3D3A36"/>
                 </a:solidFill>
-                <a:latin typeface="Calibri" pitchFamily="34" charset="0"/>
-                <a:ea typeface="Calibri" pitchFamily="34" charset="-122"/>
-                <a:cs typeface="Calibri" pitchFamily="34" charset="-120"/>
+                <a:latin typeface="Arial" pitchFamily="34" charset="0"/>
+                <a:ea typeface="Arial" pitchFamily="34" charset="-122"/>
+                <a:cs typeface="Arial" pitchFamily="34" charset="-120"/>
               </a:rPr>
-              <a:t>Independent variable (IV): what YOU change. Dependent variable (DV): what you MEASURE.</a:t>
+              <a:t>A good hypothesis is testable and specific.</a:t>
             </a:r>
             <a:endParaRPr lang="en-US" sz="1500" dirty="0"/>
           </a:p>
           <a:p>
-            <a:pPr marL="342900" indent="-342900">
+            <a:pPr>
+              <a:lnSpc>
+                <a:spcPct val="150000"/>
+              </a:lnSpc>
               <a:spcAft>
-                <a:spcPts val="800"/>
+                <a:spcPts val="600"/>
               </a:spcAft>
-              <a:buSzPct val="100000"/>
-              <a:buChar char="•"/>
             </a:pPr>
             <a:r>
               <a:rPr lang="en-US" sz="1500" dirty="0">
                 <a:solidFill>
                   <a:srgbClr val="3D3A36"/>
                 </a:solidFill>
-                <a:latin typeface="Calibri" pitchFamily="34" charset="0"/>
-                <a:ea typeface="Calibri" pitchFamily="34" charset="-122"/>
-                <a:cs typeface="Calibri" pitchFamily="34" charset="-120"/>
+                <a:latin typeface="Arial" pitchFamily="34" charset="0"/>
+                <a:ea typeface="Arial" pitchFamily="34" charset="-122"/>
+                <a:cs typeface="Arial" pitchFamily="34" charset="-120"/>
               </a:rPr>
-              <a:t>Controlled variables (CV): what you KEEP THE SAME to make it fair.</a:t>
+              <a:t>Repeat at least 3 times. Calculate the mean.</a:t>
             </a:r>
             <a:endParaRPr lang="en-US" sz="1500" dirty="0"/>
           </a:p>
           <a:p>
-            <a:pPr marL="342900" indent="-342900">
+            <a:pPr>
+              <a:lnSpc>
+                <a:spcPct val="150000"/>
+              </a:lnSpc>
               <a:spcAft>
-                <a:spcPts val="800"/>
+                <a:spcPts val="600"/>
               </a:spcAft>
-              <a:buSzPct val="100000"/>
-              <a:buChar char="•"/>
             </a:pPr>
             <a:r>
               <a:rPr lang="en-US" sz="1500" dirty="0">
                 <a:solidFill>
                   <a:srgbClr val="3D3A36"/>
                 </a:solidFill>
-                <a:latin typeface="Calibri" pitchFamily="34" charset="0"/>
-                <a:ea typeface="Calibri" pitchFamily="34" charset="-122"/>
-                <a:cs typeface="Calibri" pitchFamily="34" charset="-120"/>
+                <a:latin typeface="Arial" pitchFamily="34" charset="0"/>
+                <a:ea typeface="Arial" pitchFamily="34" charset="-122"/>
+                <a:cs typeface="Arial" pitchFamily="34" charset="-120"/>
               </a:rPr>
-              <a:t>Fair test = only ONE variable changes at a time.</a:t>
-            </a:r>
-            <a:endParaRPr lang="en-US" sz="1500" dirty="0"/>
-          </a:p>
-          <a:p>
-            <a:pPr marL="342900" indent="-342900">
-              <a:spcAft>
-                <a:spcPts val="800"/>
-              </a:spcAft>
-              <a:buSzPct val="100000"/>
-              <a:buChar char="•"/>
-            </a:pPr>
-            <a:r>
-              <a:rPr lang="en-US" sz="1500" dirty="0">
-                <a:solidFill>
-                  <a:srgbClr val="3D3A36"/>
-                </a:solidFill>
-                <a:latin typeface="Calibri" pitchFamily="34" charset="0"/>
-                <a:ea typeface="Calibri" pitchFamily="34" charset="-122"/>
-                <a:cs typeface="Calibri" pitchFamily="34" charset="-120"/>
-              </a:rPr>
-              <a:t>Repeat experiments at least 3 times and calculate the MEAN (average).</a:t>
+              <a:t>Draw a conclusion: did the results support your hypothesis?</a:t>
             </a:r>
             <a:endParaRPr lang="en-US" sz="1500" dirty="0"/>
           </a:p>
@@ -2628,6 +2771,13 @@
 <file path=ppt/slides/slide6.xml><?xml version="1.0" encoding="utf-8"?>
 <p:sld xmlns:a="http://schemas.openxmlformats.org/drawingml/2006/main" xmlns:r="http://schemas.openxmlformats.org/officeDocument/2006/relationships" xmlns:p="http://schemas.openxmlformats.org/presentationml/2006/main">
   <p:cSld name="Slide 6">
+    <p:bg>
+      <p:bgPr>
+        <a:solidFill>
+          <a:srgbClr val="111D35"/>
+        </a:solidFill>
+      </p:bgPr>
+    </p:bg>
     <p:spTree>
       <p:nvGrpSpPr>
         <p:cNvPr id="1" name=""/>
@@ -2644,54 +2794,14 @@
       </p:grpSpPr>
       <p:sp>
         <p:nvSpPr>
-          <p:cNvPr id="2" name="Shape 0"/>
+          <p:cNvPr id="2" name="Text 0"/>
           <p:cNvSpPr/>
           <p:nvPr/>
         </p:nvSpPr>
         <p:spPr>
           <a:xfrm>
-            <a:off x="0" y="0"/>
-            <a:ext cx="9144000" cy="5143500"/>
-          </a:xfrm>
-          <a:prstGeom prst="rect">
-            <a:avLst/>
-          </a:prstGeom>
-          <a:solidFill>
-            <a:srgbClr val="1B2A4A"/>
-          </a:solidFill>
-          <a:ln/>
-        </p:spPr>
-      </p:sp>
-      <p:sp>
-        <p:nvSpPr>
-          <p:cNvPr id="3" name="Shape 1"/>
-          <p:cNvSpPr/>
-          <p:nvPr/>
-        </p:nvSpPr>
-        <p:spPr>
-          <a:xfrm>
-            <a:off x="731520" y="1828800"/>
-            <a:ext cx="73152" cy="1463040"/>
-          </a:xfrm>
-          <a:prstGeom prst="rect">
-            <a:avLst/>
-          </a:prstGeom>
-          <a:solidFill>
-            <a:srgbClr val="2A9D8F"/>
-          </a:solidFill>
-          <a:ln/>
-        </p:spPr>
-      </p:sp>
-      <p:sp>
-        <p:nvSpPr>
-          <p:cNvPr id="4" name="Text 2"/>
-          <p:cNvSpPr/>
-          <p:nvPr/>
-        </p:nvSpPr>
-        <p:spPr>
-          <a:xfrm>
-            <a:off x="1097280" y="1463040"/>
-            <a:ext cx="1097280" cy="1097280"/>
+            <a:off x="731520" y="731520"/>
+            <a:ext cx="2286000" cy="1828800"/>
           </a:xfrm>
           <a:prstGeom prst="rect">
             <a:avLst/>
@@ -2703,34 +2813,36 @@
           <a:bodyPr wrap="square" rtlCol="0" anchor="ctr"/>
           <a:lstStyle/>
           <a:p>
-            <a:pPr algn="l" indent="0" marL="0">
+            <a:pPr indent="0" marL="0">
               <a:buNone/>
             </a:pPr>
             <a:r>
-              <a:rPr lang="en-US" sz="4800" b="1" dirty="0">
+              <a:rPr lang="en-US" sz="7200" b="1" dirty="0">
                 <a:solidFill>
-                  <a:srgbClr val="2A9D8F"/>
+                  <a:srgbClr val="2A9D8F">
+                    <a:alpha val="80000"/>
+                  </a:srgbClr>
                 </a:solidFill>
                 <a:latin typeface="Georgia" pitchFamily="34" charset="0"/>
                 <a:ea typeface="Georgia" pitchFamily="34" charset="-122"/>
                 <a:cs typeface="Georgia" pitchFamily="34" charset="-120"/>
               </a:rPr>
-              <a:t>3</a:t>
-            </a:r>
-            <a:endParaRPr lang="en-US" sz="4800" dirty="0"/>
-          </a:p>
-        </p:txBody>
-      </p:sp>
-      <p:sp>
-        <p:nvSpPr>
-          <p:cNvPr id="5" name="Text 3"/>
+              <a:t>03</a:t>
+            </a:r>
+            <a:endParaRPr lang="en-US" sz="7200" dirty="0"/>
+          </a:p>
+        </p:txBody>
+      </p:sp>
+      <p:sp>
+        <p:nvSpPr>
+          <p:cNvPr id="3" name="Text 1"/>
           <p:cNvSpPr/>
           <p:nvPr/>
         </p:nvSpPr>
         <p:spPr>
           <a:xfrm>
-            <a:off x="2194560" y="1920240"/>
-            <a:ext cx="5943600" cy="1097280"/>
+            <a:off x="731520" y="1828800"/>
+            <a:ext cx="9144000" cy="1097280"/>
           </a:xfrm>
           <a:prstGeom prst="rect">
             <a:avLst/>
@@ -2754,9 +2866,50 @@
                 <a:ea typeface="Georgia" pitchFamily="34" charset="-122"/>
                 <a:cs typeface="Georgia" pitchFamily="34" charset="-120"/>
               </a:rPr>
-              <a:t>Measurement &amp; Data</a:t>
+              <a:t>Variables</a:t>
             </a:r>
             <a:endParaRPr lang="en-US" sz="3200" dirty="0"/>
+          </a:p>
+        </p:txBody>
+      </p:sp>
+      <p:sp>
+        <p:nvSpPr>
+          <p:cNvPr id="4" name="Text 2"/>
+          <p:cNvSpPr/>
+          <p:nvPr/>
+        </p:nvSpPr>
+        <p:spPr>
+          <a:xfrm>
+            <a:off x="731520" y="3017520"/>
+            <a:ext cx="7315200" cy="457200"/>
+          </a:xfrm>
+          <a:prstGeom prst="rect">
+            <a:avLst/>
+          </a:prstGeom>
+          <a:noFill/>
+          <a:ln/>
+        </p:spPr>
+        <p:txBody>
+          <a:bodyPr wrap="square" rtlCol="0" anchor="ctr"/>
+          <a:lstStyle/>
+          <a:p>
+            <a:pPr indent="0" marL="0">
+              <a:buNone/>
+            </a:pPr>
+            <a:r>
+              <a:rPr lang="en-US" sz="1400" dirty="0">
+                <a:solidFill>
+                  <a:srgbClr val="FFFFFF">
+                    <a:alpha val="60000"/>
+                  </a:srgbClr>
+                </a:solidFill>
+                <a:latin typeface="Arial" pitchFamily="34" charset="0"/>
+                <a:ea typeface="Arial" pitchFamily="34" charset="-122"/>
+                <a:cs typeface="Arial" pitchFamily="34" charset="-120"/>
+              </a:rPr>
+              <a:t>Independent, dependent, controlled</a:t>
+            </a:r>
+            <a:endParaRPr lang="en-US" sz="1400" dirty="0"/>
           </a:p>
         </p:txBody>
       </p:sp>
@@ -2801,47 +2954,7 @@
         <p:spPr>
           <a:xfrm>
             <a:off x="0" y="0"/>
-            <a:ext cx="9144000" cy="822960"/>
-          </a:xfrm>
-          <a:prstGeom prst="rect">
-            <a:avLst/>
-          </a:prstGeom>
-          <a:solidFill>
-            <a:srgbClr val="FFFFFF"/>
-          </a:solidFill>
-          <a:ln/>
-        </p:spPr>
-      </p:sp>
-      <p:sp>
-        <p:nvSpPr>
-          <p:cNvPr id="3" name="Shape 1"/>
-          <p:cNvSpPr/>
-          <p:nvPr/>
-        </p:nvSpPr>
-        <p:spPr>
-          <a:xfrm>
-            <a:off x="0" y="804672"/>
-            <a:ext cx="9144000" cy="27432"/>
-          </a:xfrm>
-          <a:prstGeom prst="rect">
-            <a:avLst/>
-          </a:prstGeom>
-          <a:solidFill>
-            <a:srgbClr val="E5E2DC"/>
-          </a:solidFill>
-          <a:ln/>
-        </p:spPr>
-      </p:sp>
-      <p:sp>
-        <p:nvSpPr>
-          <p:cNvPr id="4" name="Shape 2"/>
-          <p:cNvSpPr/>
-          <p:nvPr/>
-        </p:nvSpPr>
-        <p:spPr>
-          <a:xfrm>
-            <a:off x="548640" y="201168"/>
-            <a:ext cx="54864" cy="420624"/>
+            <a:ext cx="73152" cy="5148072"/>
           </a:xfrm>
           <a:prstGeom prst="rect">
             <a:avLst/>
@@ -2854,14 +2967,14 @@
       </p:sp>
       <p:sp>
         <p:nvSpPr>
-          <p:cNvPr id="5" name="Text 3"/>
+          <p:cNvPr id="3" name="Text 1"/>
           <p:cNvSpPr/>
           <p:nvPr/>
         </p:nvSpPr>
         <p:spPr>
           <a:xfrm>
-            <a:off x="777240" y="137160"/>
-            <a:ext cx="7772400" cy="548640"/>
+            <a:off x="548640" y="274320"/>
+            <a:ext cx="9144000" cy="640080"/>
           </a:xfrm>
           <a:prstGeom prst="rect">
             <a:avLst/>
@@ -2870,14 +2983,14 @@
           <a:ln/>
         </p:spPr>
         <p:txBody>
-          <a:bodyPr wrap="square" lIns="0" tIns="0" rIns="0" bIns="0" rtlCol="0" anchor="ctr"/>
+          <a:bodyPr wrap="square" rtlCol="0" anchor="ctr"/>
           <a:lstStyle/>
           <a:p>
             <a:pPr indent="0" marL="0">
               <a:buNone/>
             </a:pPr>
             <a:r>
-              <a:rPr lang="en-US" sz="2000" b="1" dirty="0">
+              <a:rPr lang="en-US" sz="2400" b="1" dirty="0">
                 <a:solidFill>
                   <a:srgbClr val="1B2A4A"/>
                 </a:solidFill>
@@ -2885,22 +2998,42 @@
                 <a:ea typeface="Georgia" pitchFamily="34" charset="-122"/>
                 <a:cs typeface="Georgia" pitchFamily="34" charset="-120"/>
               </a:rPr>
-              <a:t>Measurement &amp; Graphs Review</a:t>
-            </a:r>
-            <a:endParaRPr lang="en-US" sz="2000" dirty="0"/>
-          </a:p>
-        </p:txBody>
-      </p:sp>
-      <p:sp>
-        <p:nvSpPr>
-          <p:cNvPr id="6" name="Text 4"/>
+              <a:t>Variables Recap</a:t>
+            </a:r>
+            <a:endParaRPr lang="en-US" sz="2400" dirty="0"/>
+          </a:p>
+        </p:txBody>
+      </p:sp>
+      <p:sp>
+        <p:nvSpPr>
+          <p:cNvPr id="4" name="Shape 2"/>
           <p:cNvSpPr/>
           <p:nvPr/>
         </p:nvSpPr>
         <p:spPr>
           <a:xfrm>
-            <a:off x="731520" y="1051560"/>
-            <a:ext cx="7680960" cy="3108960"/>
+            <a:off x="548640" y="960120"/>
+            <a:ext cx="2286000" cy="36576"/>
+          </a:xfrm>
+          <a:prstGeom prst="rect">
+            <a:avLst/>
+          </a:prstGeom>
+          <a:solidFill>
+            <a:srgbClr val="2A9D8F"/>
+          </a:solidFill>
+          <a:ln/>
+        </p:spPr>
+      </p:sp>
+      <p:sp>
+        <p:nvSpPr>
+          <p:cNvPr id="5" name="Text 3"/>
+          <p:cNvSpPr/>
+          <p:nvPr/>
+        </p:nvSpPr>
+        <p:spPr>
+          <a:xfrm>
+            <a:off x="548640" y="1188720"/>
+            <a:ext cx="10058400" cy="3474720"/>
           </a:xfrm>
           <a:prstGeom prst="rect">
             <a:avLst/>
@@ -2912,128 +3045,68 @@
           <a:bodyPr wrap="square" rtlCol="0" anchor="t"/>
           <a:lstStyle/>
           <a:p>
-            <a:pPr marL="342900" indent="-342900">
+            <a:pPr>
+              <a:lnSpc>
+                <a:spcPct val="150000"/>
+              </a:lnSpc>
               <a:spcAft>
-                <a:spcPts val="800"/>
+                <a:spcPts val="600"/>
               </a:spcAft>
-              <a:buSzPct val="100000"/>
-              <a:buChar char="•"/>
             </a:pPr>
             <a:r>
               <a:rPr lang="en-US" sz="1500" dirty="0">
                 <a:solidFill>
                   <a:srgbClr val="3D3A36"/>
                 </a:solidFill>
-                <a:latin typeface="Calibri" pitchFamily="34" charset="0"/>
-                <a:ea typeface="Calibri" pitchFamily="34" charset="-122"/>
-                <a:cs typeface="Calibri" pitchFamily="34" charset="-120"/>
+                <a:latin typeface="Arial" pitchFamily="34" charset="0"/>
+                <a:ea typeface="Arial" pitchFamily="34" charset="-122"/>
+                <a:cs typeface="Arial" pitchFamily="34" charset="-120"/>
               </a:rPr>
-              <a:t>SI units: length (m), mass (kg), time (s), temperature (°C), volume (cm³).</a:t>
+              <a:t>Independent: what YOU change. Dependent: what you MEASURE.</a:t>
             </a:r>
             <a:endParaRPr lang="en-US" sz="1500" dirty="0"/>
           </a:p>
           <a:p>
-            <a:pPr marL="342900" indent="-342900">
+            <a:pPr>
+              <a:lnSpc>
+                <a:spcPct val="150000"/>
+              </a:lnSpc>
               <a:spcAft>
-                <a:spcPts val="800"/>
+                <a:spcPts val="600"/>
               </a:spcAft>
-              <a:buSzPct val="100000"/>
-              <a:buChar char="•"/>
             </a:pPr>
             <a:r>
               <a:rPr lang="en-US" sz="1500" dirty="0">
                 <a:solidFill>
                   <a:srgbClr val="3D3A36"/>
                 </a:solidFill>
-                <a:latin typeface="Calibri" pitchFamily="34" charset="0"/>
-                <a:ea typeface="Calibri" pitchFamily="34" charset="-122"/>
-                <a:cs typeface="Calibri" pitchFamily="34" charset="-120"/>
+                <a:latin typeface="Arial" pitchFamily="34" charset="0"/>
+                <a:ea typeface="Arial" pitchFamily="34" charset="-122"/>
+                <a:cs typeface="Arial" pitchFamily="34" charset="-120"/>
               </a:rPr>
-              <a:t>Read a measuring cylinder at the MENISCUS at EYE LEVEL.</a:t>
+              <a:t>Controlled: everything you keep the SAME.</a:t>
             </a:r>
             <a:endParaRPr lang="en-US" sz="1500" dirty="0"/>
           </a:p>
           <a:p>
-            <a:pPr marL="342900" indent="-342900">
+            <a:pPr>
+              <a:lnSpc>
+                <a:spcPct val="150000"/>
+              </a:lnSpc>
               <a:spcAft>
-                <a:spcPts val="800"/>
+                <a:spcPts val="600"/>
               </a:spcAft>
-              <a:buSzPct val="100000"/>
-              <a:buChar char="•"/>
             </a:pPr>
             <a:r>
               <a:rPr lang="en-US" sz="1500" dirty="0">
                 <a:solidFill>
                   <a:srgbClr val="3D3A36"/>
                 </a:solidFill>
-                <a:latin typeface="Calibri" pitchFamily="34" charset="0"/>
-                <a:ea typeface="Calibri" pitchFamily="34" charset="-122"/>
-                <a:cs typeface="Calibri" pitchFamily="34" charset="-120"/>
+                <a:latin typeface="Arial" pitchFamily="34" charset="0"/>
+                <a:ea typeface="Arial" pitchFamily="34" charset="-122"/>
+                <a:cs typeface="Arial" pitchFamily="34" charset="-120"/>
               </a:rPr>
-              <a:t>Accuracy = close to true value. Precision = repeated results close together.</a:t>
-            </a:r>
-            <a:endParaRPr lang="en-US" sz="1500" dirty="0"/>
-          </a:p>
-          <a:p>
-            <a:pPr marL="342900" indent="-342900">
-              <a:spcAft>
-                <a:spcPts val="800"/>
-              </a:spcAft>
-              <a:buSzPct val="100000"/>
-              <a:buChar char="•"/>
-            </a:pPr>
-            <a:r>
-              <a:rPr lang="en-US" sz="1500" dirty="0">
-                <a:solidFill>
-                  <a:srgbClr val="3D3A36"/>
-                </a:solidFill>
-                <a:latin typeface="Calibri" pitchFamily="34" charset="0"/>
-                <a:ea typeface="Calibri" pitchFamily="34" charset="-122"/>
-                <a:cs typeface="Calibri" pitchFamily="34" charset="-120"/>
-              </a:rPr>
-              <a:t>Bar chart for CATEGORICAL data (bars don't touch).</a:t>
-            </a:r>
-            <a:endParaRPr lang="en-US" sz="1500" dirty="0"/>
-          </a:p>
-          <a:p>
-            <a:pPr marL="342900" indent="-342900">
-              <a:spcAft>
-                <a:spcPts val="800"/>
-              </a:spcAft>
-              <a:buSzPct val="100000"/>
-              <a:buChar char="•"/>
-            </a:pPr>
-            <a:r>
-              <a:rPr lang="en-US" sz="1500" dirty="0">
-                <a:solidFill>
-                  <a:srgbClr val="3D3A36"/>
-                </a:solidFill>
-                <a:latin typeface="Calibri" pitchFamily="34" charset="0"/>
-                <a:ea typeface="Calibri" pitchFamily="34" charset="-122"/>
-                <a:cs typeface="Calibri" pitchFamily="34" charset="-120"/>
-              </a:rPr>
-              <a:t>Line graph for CONTINUOUS data (points connected by lines).</a:t>
-            </a:r>
-            <a:endParaRPr lang="en-US" sz="1500" dirty="0"/>
-          </a:p>
-          <a:p>
-            <a:pPr marL="342900" indent="-342900">
-              <a:spcAft>
-                <a:spcPts val="800"/>
-              </a:spcAft>
-              <a:buSzPct val="100000"/>
-              <a:buChar char="•"/>
-            </a:pPr>
-            <a:r>
-              <a:rPr lang="en-US" sz="1500" dirty="0">
-                <a:solidFill>
-                  <a:srgbClr val="3D3A36"/>
-                </a:solidFill>
-                <a:latin typeface="Calibri" pitchFamily="34" charset="0"/>
-                <a:ea typeface="Calibri" pitchFamily="34" charset="-122"/>
-                <a:cs typeface="Calibri" pitchFamily="34" charset="-120"/>
-              </a:rPr>
-              <a:t>Always label axes with variable name AND unit.</a:t>
+              <a:t>Fair test: only ONE variable changes at a time.</a:t>
             </a:r>
             <a:endParaRPr lang="en-US" sz="1500" dirty="0"/>
           </a:p>
@@ -3050,6 +3123,159 @@
 <file path=ppt/slides/slide8.xml><?xml version="1.0" encoding="utf-8"?>
 <p:sld xmlns:a="http://schemas.openxmlformats.org/drawingml/2006/main" xmlns:r="http://schemas.openxmlformats.org/officeDocument/2006/relationships" xmlns:p="http://schemas.openxmlformats.org/presentationml/2006/main">
   <p:cSld name="Slide 8">
+    <p:bg>
+      <p:bgPr>
+        <a:solidFill>
+          <a:srgbClr val="111D35"/>
+        </a:solidFill>
+      </p:bgPr>
+    </p:bg>
+    <p:spTree>
+      <p:nvGrpSpPr>
+        <p:cNvPr id="1" name=""/>
+        <p:cNvGrpSpPr/>
+        <p:nvPr/>
+      </p:nvGrpSpPr>
+      <p:grpSpPr>
+        <a:xfrm>
+          <a:off x="0" y="0"/>
+          <a:ext cx="0" cy="0"/>
+          <a:chOff x="0" y="0"/>
+          <a:chExt cx="0" cy="0"/>
+        </a:xfrm>
+      </p:grpSpPr>
+      <p:sp>
+        <p:nvSpPr>
+          <p:cNvPr id="2" name="Text 0"/>
+          <p:cNvSpPr/>
+          <p:nvPr/>
+        </p:nvSpPr>
+        <p:spPr>
+          <a:xfrm>
+            <a:off x="731520" y="731520"/>
+            <a:ext cx="2286000" cy="1828800"/>
+          </a:xfrm>
+          <a:prstGeom prst="rect">
+            <a:avLst/>
+          </a:prstGeom>
+          <a:noFill/>
+          <a:ln/>
+        </p:spPr>
+        <p:txBody>
+          <a:bodyPr wrap="square" rtlCol="0" anchor="ctr"/>
+          <a:lstStyle/>
+          <a:p>
+            <a:pPr indent="0" marL="0">
+              <a:buNone/>
+            </a:pPr>
+            <a:r>
+              <a:rPr lang="en-US" sz="7200" b="1" dirty="0">
+                <a:solidFill>
+                  <a:srgbClr val="2A9D8F">
+                    <a:alpha val="80000"/>
+                  </a:srgbClr>
+                </a:solidFill>
+                <a:latin typeface="Georgia" pitchFamily="34" charset="0"/>
+                <a:ea typeface="Georgia" pitchFamily="34" charset="-122"/>
+                <a:cs typeface="Georgia" pitchFamily="34" charset="-120"/>
+              </a:rPr>
+              <a:t>04</a:t>
+            </a:r>
+            <a:endParaRPr lang="en-US" sz="7200" dirty="0"/>
+          </a:p>
+        </p:txBody>
+      </p:sp>
+      <p:sp>
+        <p:nvSpPr>
+          <p:cNvPr id="3" name="Text 1"/>
+          <p:cNvSpPr/>
+          <p:nvPr/>
+        </p:nvSpPr>
+        <p:spPr>
+          <a:xfrm>
+            <a:off x="731520" y="1828800"/>
+            <a:ext cx="9144000" cy="1097280"/>
+          </a:xfrm>
+          <a:prstGeom prst="rect">
+            <a:avLst/>
+          </a:prstGeom>
+          <a:noFill/>
+          <a:ln/>
+        </p:spPr>
+        <p:txBody>
+          <a:bodyPr wrap="square" rtlCol="0" anchor="ctr"/>
+          <a:lstStyle/>
+          <a:p>
+            <a:pPr indent="0" marL="0">
+              <a:buNone/>
+            </a:pPr>
+            <a:r>
+              <a:rPr lang="en-US" sz="3200" b="1" dirty="0">
+                <a:solidFill>
+                  <a:srgbClr val="FFFFFF"/>
+                </a:solidFill>
+                <a:latin typeface="Georgia" pitchFamily="34" charset="0"/>
+                <a:ea typeface="Georgia" pitchFamily="34" charset="-122"/>
+                <a:cs typeface="Georgia" pitchFamily="34" charset="-120"/>
+              </a:rPr>
+              <a:t>Measurement &amp; Graphs</a:t>
+            </a:r>
+            <a:endParaRPr lang="en-US" sz="3200" dirty="0"/>
+          </a:p>
+        </p:txBody>
+      </p:sp>
+      <p:sp>
+        <p:nvSpPr>
+          <p:cNvPr id="4" name="Text 2"/>
+          <p:cNvSpPr/>
+          <p:nvPr/>
+        </p:nvSpPr>
+        <p:spPr>
+          <a:xfrm>
+            <a:off x="731520" y="3017520"/>
+            <a:ext cx="7315200" cy="457200"/>
+          </a:xfrm>
+          <a:prstGeom prst="rect">
+            <a:avLst/>
+          </a:prstGeom>
+          <a:noFill/>
+          <a:ln/>
+        </p:spPr>
+        <p:txBody>
+          <a:bodyPr wrap="square" rtlCol="0" anchor="ctr"/>
+          <a:lstStyle/>
+          <a:p>
+            <a:pPr indent="0" marL="0">
+              <a:buNone/>
+            </a:pPr>
+            <a:r>
+              <a:rPr lang="en-US" sz="1400" dirty="0">
+                <a:solidFill>
+                  <a:srgbClr val="FFFFFF">
+                    <a:alpha val="60000"/>
+                  </a:srgbClr>
+                </a:solidFill>
+                <a:latin typeface="Arial" pitchFamily="34" charset="0"/>
+                <a:ea typeface="Arial" pitchFamily="34" charset="-122"/>
+                <a:cs typeface="Arial" pitchFamily="34" charset="-120"/>
+              </a:rPr>
+              <a:t>Units, accuracy, and data presentation</a:t>
+            </a:r>
+            <a:endParaRPr lang="en-US" sz="1400" dirty="0"/>
+          </a:p>
+        </p:txBody>
+      </p:sp>
+    </p:spTree>
+  </p:cSld>
+  <p:clrMapOvr>
+    <a:masterClrMapping/>
+  </p:clrMapOvr>
+</p:sld>
+</file>
+
+<file path=ppt/slides/slide9.xml><?xml version="1.0" encoding="utf-8"?>
+<p:sld xmlns:a="http://schemas.openxmlformats.org/drawingml/2006/main" xmlns:r="http://schemas.openxmlformats.org/officeDocument/2006/relationships" xmlns:p="http://schemas.openxmlformats.org/presentationml/2006/main">
+  <p:cSld name="Slide 9">
     <p:bg>
       <p:bgPr>
         <a:solidFill>
@@ -3080,47 +3306,7 @@
         <p:spPr>
           <a:xfrm>
             <a:off x="0" y="0"/>
-            <a:ext cx="9144000" cy="822960"/>
-          </a:xfrm>
-          <a:prstGeom prst="rect">
-            <a:avLst/>
-          </a:prstGeom>
-          <a:solidFill>
-            <a:srgbClr val="FFFFFF"/>
-          </a:solidFill>
-          <a:ln/>
-        </p:spPr>
-      </p:sp>
-      <p:sp>
-        <p:nvSpPr>
-          <p:cNvPr id="3" name="Shape 1"/>
-          <p:cNvSpPr/>
-          <p:nvPr/>
-        </p:nvSpPr>
-        <p:spPr>
-          <a:xfrm>
-            <a:off x="0" y="804672"/>
-            <a:ext cx="9144000" cy="27432"/>
-          </a:xfrm>
-          <a:prstGeom prst="rect">
-            <a:avLst/>
-          </a:prstGeom>
-          <a:solidFill>
-            <a:srgbClr val="E5E2DC"/>
-          </a:solidFill>
-          <a:ln/>
-        </p:spPr>
-      </p:sp>
-      <p:sp>
-        <p:nvSpPr>
-          <p:cNvPr id="4" name="Shape 2"/>
-          <p:cNvSpPr/>
-          <p:nvPr/>
-        </p:nvSpPr>
-        <p:spPr>
-          <a:xfrm>
-            <a:off x="548640" y="201168"/>
-            <a:ext cx="54864" cy="420624"/>
+            <a:ext cx="73152" cy="5148072"/>
           </a:xfrm>
           <a:prstGeom prst="rect">
             <a:avLst/>
@@ -3133,14 +3319,14 @@
       </p:sp>
       <p:sp>
         <p:nvSpPr>
-          <p:cNvPr id="5" name="Text 3"/>
+          <p:cNvPr id="3" name="Text 1"/>
           <p:cNvSpPr/>
           <p:nvPr/>
         </p:nvSpPr>
         <p:spPr>
           <a:xfrm>
-            <a:off x="777240" y="137160"/>
-            <a:ext cx="7772400" cy="548640"/>
+            <a:off x="548640" y="274320"/>
+            <a:ext cx="9144000" cy="640080"/>
           </a:xfrm>
           <a:prstGeom prst="rect">
             <a:avLst/>
@@ -3149,14 +3335,14 @@
           <a:ln/>
         </p:spPr>
         <p:txBody>
-          <a:bodyPr wrap="square" lIns="0" tIns="0" rIns="0" bIns="0" rtlCol="0" anchor="ctr"/>
+          <a:bodyPr wrap="square" rtlCol="0" anchor="ctr"/>
           <a:lstStyle/>
           <a:p>
             <a:pPr indent="0" marL="0">
               <a:buNone/>
             </a:pPr>
             <a:r>
-              <a:rPr lang="en-US" sz="2000" b="1" dirty="0">
+              <a:rPr lang="en-US" sz="2400" b="1" dirty="0">
                 <a:solidFill>
                   <a:srgbClr val="1B2A4A"/>
                 </a:solidFill>
@@ -3164,717 +3350,22 @@
                 <a:ea typeface="Georgia" pitchFamily="34" charset="-122"/>
                 <a:cs typeface="Georgia" pitchFamily="34" charset="-120"/>
               </a:rPr>
-              <a:t>Final Revision Checklist</a:t>
-            </a:r>
-            <a:endParaRPr lang="en-US" sz="2000" dirty="0"/>
-          </a:p>
-        </p:txBody>
-      </p:sp>
-      <p:sp>
-        <p:nvSpPr>
-          <p:cNvPr id="6" name="Shape 4"/>
+              <a:t>Measurement &amp; Graphs Recap</a:t>
+            </a:r>
+            <a:endParaRPr lang="en-US" sz="2400" dirty="0"/>
+          </a:p>
+        </p:txBody>
+      </p:sp>
+      <p:sp>
+        <p:nvSpPr>
+          <p:cNvPr id="4" name="Shape 2"/>
           <p:cNvSpPr/>
           <p:nvPr/>
         </p:nvSpPr>
         <p:spPr>
           <a:xfrm>
-            <a:off x="731520" y="1051560"/>
-            <a:ext cx="7680960" cy="438912"/>
-          </a:xfrm>
-          <a:prstGeom prst="rect">
-            <a:avLst/>
-          </a:prstGeom>
-          <a:solidFill>
-            <a:srgbClr val="FFFFFF"/>
-          </a:solidFill>
-          <a:ln/>
-        </p:spPr>
-      </p:sp>
-      <p:sp>
-        <p:nvSpPr>
-          <p:cNvPr id="7" name="Text 5"/>
-          <p:cNvSpPr/>
-          <p:nvPr/>
-        </p:nvSpPr>
-        <p:spPr>
-          <a:xfrm>
-            <a:off x="868680" y="1051560"/>
-            <a:ext cx="320040" cy="438912"/>
-          </a:xfrm>
-          <a:prstGeom prst="rect">
-            <a:avLst/>
-          </a:prstGeom>
-          <a:noFill/>
-          <a:ln/>
-        </p:spPr>
-        <p:txBody>
-          <a:bodyPr wrap="square" rtlCol="0" anchor="ctr"/>
-          <a:lstStyle/>
-          <a:p>
-            <a:pPr indent="0" marL="0">
-              <a:buNone/>
-            </a:pPr>
-            <a:r>
-              <a:rPr lang="en-US" sz="1400" dirty="0">
-                <a:solidFill>
-                  <a:srgbClr val="2A9D8F"/>
-                </a:solidFill>
-              </a:rPr>
-              <a:t>☐</a:t>
-            </a:r>
-            <a:endParaRPr lang="en-US" sz="1400" dirty="0"/>
-          </a:p>
-        </p:txBody>
-      </p:sp>
-      <p:sp>
-        <p:nvSpPr>
-          <p:cNvPr id="8" name="Text 6"/>
-          <p:cNvSpPr/>
-          <p:nvPr/>
-        </p:nvSpPr>
-        <p:spPr>
-          <a:xfrm>
-            <a:off x="1234440" y="1051560"/>
-            <a:ext cx="6949440" cy="438912"/>
-          </a:xfrm>
-          <a:prstGeom prst="rect">
-            <a:avLst/>
-          </a:prstGeom>
-          <a:noFill/>
-          <a:ln/>
-        </p:spPr>
-        <p:txBody>
-          <a:bodyPr wrap="square" rtlCol="0" anchor="ctr"/>
-          <a:lstStyle/>
-          <a:p>
-            <a:pPr indent="0" marL="0">
-              <a:buNone/>
-            </a:pPr>
-            <a:r>
-              <a:rPr lang="en-US" sz="1300" dirty="0">
-                <a:solidFill>
-                  <a:srgbClr val="3D3A36"/>
-                </a:solidFill>
-                <a:latin typeface="Calibri" pitchFamily="34" charset="0"/>
-                <a:ea typeface="Calibri" pitchFamily="34" charset="-122"/>
-                <a:cs typeface="Calibri" pitchFamily="34" charset="-120"/>
-              </a:rPr>
-              <a:t>Lab safety rules and hazard symbols</a:t>
-            </a:r>
-            <a:endParaRPr lang="en-US" sz="1300" dirty="0"/>
-          </a:p>
-        </p:txBody>
-      </p:sp>
-      <p:sp>
-        <p:nvSpPr>
-          <p:cNvPr id="9" name="Shape 7"/>
-          <p:cNvSpPr/>
-          <p:nvPr/>
-        </p:nvSpPr>
-        <p:spPr>
-          <a:xfrm>
-            <a:off x="731520" y="1554480"/>
-            <a:ext cx="7680960" cy="438912"/>
-          </a:xfrm>
-          <a:prstGeom prst="rect">
-            <a:avLst/>
-          </a:prstGeom>
-          <a:solidFill>
-            <a:srgbClr val="F8F6F3"/>
-          </a:solidFill>
-          <a:ln/>
-        </p:spPr>
-      </p:sp>
-      <p:sp>
-        <p:nvSpPr>
-          <p:cNvPr id="10" name="Text 8"/>
-          <p:cNvSpPr/>
-          <p:nvPr/>
-        </p:nvSpPr>
-        <p:spPr>
-          <a:xfrm>
-            <a:off x="868680" y="1554480"/>
-            <a:ext cx="320040" cy="438912"/>
-          </a:xfrm>
-          <a:prstGeom prst="rect">
-            <a:avLst/>
-          </a:prstGeom>
-          <a:noFill/>
-          <a:ln/>
-        </p:spPr>
-        <p:txBody>
-          <a:bodyPr wrap="square" rtlCol="0" anchor="ctr"/>
-          <a:lstStyle/>
-          <a:p>
-            <a:pPr indent="0" marL="0">
-              <a:buNone/>
-            </a:pPr>
-            <a:r>
-              <a:rPr lang="en-US" sz="1400" dirty="0">
-                <a:solidFill>
-                  <a:srgbClr val="2A9D8F"/>
-                </a:solidFill>
-              </a:rPr>
-              <a:t>☐</a:t>
-            </a:r>
-            <a:endParaRPr lang="en-US" sz="1400" dirty="0"/>
-          </a:p>
-        </p:txBody>
-      </p:sp>
-      <p:sp>
-        <p:nvSpPr>
-          <p:cNvPr id="11" name="Text 9"/>
-          <p:cNvSpPr/>
-          <p:nvPr/>
-        </p:nvSpPr>
-        <p:spPr>
-          <a:xfrm>
-            <a:off x="1234440" y="1554480"/>
-            <a:ext cx="6949440" cy="438912"/>
-          </a:xfrm>
-          <a:prstGeom prst="rect">
-            <a:avLst/>
-          </a:prstGeom>
-          <a:noFill/>
-          <a:ln/>
-        </p:spPr>
-        <p:txBody>
-          <a:bodyPr wrap="square" rtlCol="0" anchor="ctr"/>
-          <a:lstStyle/>
-          <a:p>
-            <a:pPr indent="0" marL="0">
-              <a:buNone/>
-            </a:pPr>
-            <a:r>
-              <a:rPr lang="en-US" sz="1300" dirty="0">
-                <a:solidFill>
-                  <a:srgbClr val="3D3A36"/>
-                </a:solidFill>
-                <a:latin typeface="Calibri" pitchFamily="34" charset="0"/>
-                <a:ea typeface="Calibri" pitchFamily="34" charset="-122"/>
-                <a:cs typeface="Calibri" pitchFamily="34" charset="-120"/>
-              </a:rPr>
-              <a:t>Steps of the scientific method</a:t>
-            </a:r>
-            <a:endParaRPr lang="en-US" sz="1300" dirty="0"/>
-          </a:p>
-        </p:txBody>
-      </p:sp>
-      <p:sp>
-        <p:nvSpPr>
-          <p:cNvPr id="12" name="Shape 10"/>
-          <p:cNvSpPr/>
-          <p:nvPr/>
-        </p:nvSpPr>
-        <p:spPr>
-          <a:xfrm>
-            <a:off x="731520" y="2057400"/>
-            <a:ext cx="7680960" cy="438912"/>
-          </a:xfrm>
-          <a:prstGeom prst="rect">
-            <a:avLst/>
-          </a:prstGeom>
-          <a:solidFill>
-            <a:srgbClr val="FFFFFF"/>
-          </a:solidFill>
-          <a:ln/>
-        </p:spPr>
-      </p:sp>
-      <p:sp>
-        <p:nvSpPr>
-          <p:cNvPr id="13" name="Text 11"/>
-          <p:cNvSpPr/>
-          <p:nvPr/>
-        </p:nvSpPr>
-        <p:spPr>
-          <a:xfrm>
-            <a:off x="868680" y="2057400"/>
-            <a:ext cx="320040" cy="438912"/>
-          </a:xfrm>
-          <a:prstGeom prst="rect">
-            <a:avLst/>
-          </a:prstGeom>
-          <a:noFill/>
-          <a:ln/>
-        </p:spPr>
-        <p:txBody>
-          <a:bodyPr wrap="square" rtlCol="0" anchor="ctr"/>
-          <a:lstStyle/>
-          <a:p>
-            <a:pPr indent="0" marL="0">
-              <a:buNone/>
-            </a:pPr>
-            <a:r>
-              <a:rPr lang="en-US" sz="1400" dirty="0">
-                <a:solidFill>
-                  <a:srgbClr val="2A9D8F"/>
-                </a:solidFill>
-              </a:rPr>
-              <a:t>☐</a:t>
-            </a:r>
-            <a:endParaRPr lang="en-US" sz="1400" dirty="0"/>
-          </a:p>
-        </p:txBody>
-      </p:sp>
-      <p:sp>
-        <p:nvSpPr>
-          <p:cNvPr id="14" name="Text 12"/>
-          <p:cNvSpPr/>
-          <p:nvPr/>
-        </p:nvSpPr>
-        <p:spPr>
-          <a:xfrm>
-            <a:off x="1234440" y="2057400"/>
-            <a:ext cx="6949440" cy="438912"/>
-          </a:xfrm>
-          <a:prstGeom prst="rect">
-            <a:avLst/>
-          </a:prstGeom>
-          <a:noFill/>
-          <a:ln/>
-        </p:spPr>
-        <p:txBody>
-          <a:bodyPr wrap="square" rtlCol="0" anchor="ctr"/>
-          <a:lstStyle/>
-          <a:p>
-            <a:pPr indent="0" marL="0">
-              <a:buNone/>
-            </a:pPr>
-            <a:r>
-              <a:rPr lang="en-US" sz="1300" dirty="0">
-                <a:solidFill>
-                  <a:srgbClr val="3D3A36"/>
-                </a:solidFill>
-                <a:latin typeface="Calibri" pitchFamily="34" charset="0"/>
-                <a:ea typeface="Calibri" pitchFamily="34" charset="-122"/>
-                <a:cs typeface="Calibri" pitchFamily="34" charset="-120"/>
-              </a:rPr>
-              <a:t>Three types of variables (IV, DV, CV)</a:t>
-            </a:r>
-            <a:endParaRPr lang="en-US" sz="1300" dirty="0"/>
-          </a:p>
-        </p:txBody>
-      </p:sp>
-      <p:sp>
-        <p:nvSpPr>
-          <p:cNvPr id="15" name="Shape 13"/>
-          <p:cNvSpPr/>
-          <p:nvPr/>
-        </p:nvSpPr>
-        <p:spPr>
-          <a:xfrm>
-            <a:off x="731520" y="2560320"/>
-            <a:ext cx="7680960" cy="438912"/>
-          </a:xfrm>
-          <a:prstGeom prst="rect">
-            <a:avLst/>
-          </a:prstGeom>
-          <a:solidFill>
-            <a:srgbClr val="F8F6F3"/>
-          </a:solidFill>
-          <a:ln/>
-        </p:spPr>
-      </p:sp>
-      <p:sp>
-        <p:nvSpPr>
-          <p:cNvPr id="16" name="Text 14"/>
-          <p:cNvSpPr/>
-          <p:nvPr/>
-        </p:nvSpPr>
-        <p:spPr>
-          <a:xfrm>
-            <a:off x="868680" y="2560320"/>
-            <a:ext cx="320040" cy="438912"/>
-          </a:xfrm>
-          <a:prstGeom prst="rect">
-            <a:avLst/>
-          </a:prstGeom>
-          <a:noFill/>
-          <a:ln/>
-        </p:spPr>
-        <p:txBody>
-          <a:bodyPr wrap="square" rtlCol="0" anchor="ctr"/>
-          <a:lstStyle/>
-          <a:p>
-            <a:pPr indent="0" marL="0">
-              <a:buNone/>
-            </a:pPr>
-            <a:r>
-              <a:rPr lang="en-US" sz="1400" dirty="0">
-                <a:solidFill>
-                  <a:srgbClr val="2A9D8F"/>
-                </a:solidFill>
-              </a:rPr>
-              <a:t>☐</a:t>
-            </a:r>
-            <a:endParaRPr lang="en-US" sz="1400" dirty="0"/>
-          </a:p>
-        </p:txBody>
-      </p:sp>
-      <p:sp>
-        <p:nvSpPr>
-          <p:cNvPr id="17" name="Text 15"/>
-          <p:cNvSpPr/>
-          <p:nvPr/>
-        </p:nvSpPr>
-        <p:spPr>
-          <a:xfrm>
-            <a:off x="1234440" y="2560320"/>
-            <a:ext cx="6949440" cy="438912"/>
-          </a:xfrm>
-          <a:prstGeom prst="rect">
-            <a:avLst/>
-          </a:prstGeom>
-          <a:noFill/>
-          <a:ln/>
-        </p:spPr>
-        <p:txBody>
-          <a:bodyPr wrap="square" rtlCol="0" anchor="ctr"/>
-          <a:lstStyle/>
-          <a:p>
-            <a:pPr indent="0" marL="0">
-              <a:buNone/>
-            </a:pPr>
-            <a:r>
-              <a:rPr lang="en-US" sz="1300" dirty="0">
-                <a:solidFill>
-                  <a:srgbClr val="3D3A36"/>
-                </a:solidFill>
-                <a:latin typeface="Calibri" pitchFamily="34" charset="0"/>
-                <a:ea typeface="Calibri" pitchFamily="34" charset="-122"/>
-                <a:cs typeface="Calibri" pitchFamily="34" charset="-120"/>
-              </a:rPr>
-              <a:t>Writing a testable hypothesis</a:t>
-            </a:r>
-            <a:endParaRPr lang="en-US" sz="1300" dirty="0"/>
-          </a:p>
-        </p:txBody>
-      </p:sp>
-      <p:sp>
-        <p:nvSpPr>
-          <p:cNvPr id="18" name="Shape 16"/>
-          <p:cNvSpPr/>
-          <p:nvPr/>
-        </p:nvSpPr>
-        <p:spPr>
-          <a:xfrm>
-            <a:off x="731520" y="3063240"/>
-            <a:ext cx="7680960" cy="438912"/>
-          </a:xfrm>
-          <a:prstGeom prst="rect">
-            <a:avLst/>
-          </a:prstGeom>
-          <a:solidFill>
-            <a:srgbClr val="FFFFFF"/>
-          </a:solidFill>
-          <a:ln/>
-        </p:spPr>
-      </p:sp>
-      <p:sp>
-        <p:nvSpPr>
-          <p:cNvPr id="19" name="Text 17"/>
-          <p:cNvSpPr/>
-          <p:nvPr/>
-        </p:nvSpPr>
-        <p:spPr>
-          <a:xfrm>
-            <a:off x="868680" y="3063240"/>
-            <a:ext cx="320040" cy="438912"/>
-          </a:xfrm>
-          <a:prstGeom prst="rect">
-            <a:avLst/>
-          </a:prstGeom>
-          <a:noFill/>
-          <a:ln/>
-        </p:spPr>
-        <p:txBody>
-          <a:bodyPr wrap="square" rtlCol="0" anchor="ctr"/>
-          <a:lstStyle/>
-          <a:p>
-            <a:pPr indent="0" marL="0">
-              <a:buNone/>
-            </a:pPr>
-            <a:r>
-              <a:rPr lang="en-US" sz="1400" dirty="0">
-                <a:solidFill>
-                  <a:srgbClr val="2A9D8F"/>
-                </a:solidFill>
-              </a:rPr>
-              <a:t>☐</a:t>
-            </a:r>
-            <a:endParaRPr lang="en-US" sz="1400" dirty="0"/>
-          </a:p>
-        </p:txBody>
-      </p:sp>
-      <p:sp>
-        <p:nvSpPr>
-          <p:cNvPr id="20" name="Text 18"/>
-          <p:cNvSpPr/>
-          <p:nvPr/>
-        </p:nvSpPr>
-        <p:spPr>
-          <a:xfrm>
-            <a:off x="1234440" y="3063240"/>
-            <a:ext cx="6949440" cy="438912"/>
-          </a:xfrm>
-          <a:prstGeom prst="rect">
-            <a:avLst/>
-          </a:prstGeom>
-          <a:noFill/>
-          <a:ln/>
-        </p:spPr>
-        <p:txBody>
-          <a:bodyPr wrap="square" rtlCol="0" anchor="ctr"/>
-          <a:lstStyle/>
-          <a:p>
-            <a:pPr indent="0" marL="0">
-              <a:buNone/>
-            </a:pPr>
-            <a:r>
-              <a:rPr lang="en-US" sz="1300" dirty="0">
-                <a:solidFill>
-                  <a:srgbClr val="3D3A36"/>
-                </a:solidFill>
-                <a:latin typeface="Calibri" pitchFamily="34" charset="0"/>
-                <a:ea typeface="Calibri" pitchFamily="34" charset="-122"/>
-                <a:cs typeface="Calibri" pitchFamily="34" charset="-120"/>
-              </a:rPr>
-              <a:t>SI units and measurement techniques</a:t>
-            </a:r>
-            <a:endParaRPr lang="en-US" sz="1300" dirty="0"/>
-          </a:p>
-        </p:txBody>
-      </p:sp>
-      <p:sp>
-        <p:nvSpPr>
-          <p:cNvPr id="21" name="Shape 19"/>
-          <p:cNvSpPr/>
-          <p:nvPr/>
-        </p:nvSpPr>
-        <p:spPr>
-          <a:xfrm>
-            <a:off x="731520" y="3566160"/>
-            <a:ext cx="7680960" cy="438912"/>
-          </a:xfrm>
-          <a:prstGeom prst="rect">
-            <a:avLst/>
-          </a:prstGeom>
-          <a:solidFill>
-            <a:srgbClr val="F8F6F3"/>
-          </a:solidFill>
-          <a:ln/>
-        </p:spPr>
-      </p:sp>
-      <p:sp>
-        <p:nvSpPr>
-          <p:cNvPr id="22" name="Text 20"/>
-          <p:cNvSpPr/>
-          <p:nvPr/>
-        </p:nvSpPr>
-        <p:spPr>
-          <a:xfrm>
-            <a:off x="868680" y="3566160"/>
-            <a:ext cx="320040" cy="438912"/>
-          </a:xfrm>
-          <a:prstGeom prst="rect">
-            <a:avLst/>
-          </a:prstGeom>
-          <a:noFill/>
-          <a:ln/>
-        </p:spPr>
-        <p:txBody>
-          <a:bodyPr wrap="square" rtlCol="0" anchor="ctr"/>
-          <a:lstStyle/>
-          <a:p>
-            <a:pPr indent="0" marL="0">
-              <a:buNone/>
-            </a:pPr>
-            <a:r>
-              <a:rPr lang="en-US" sz="1400" dirty="0">
-                <a:solidFill>
-                  <a:srgbClr val="2A9D8F"/>
-                </a:solidFill>
-              </a:rPr>
-              <a:t>☐</a:t>
-            </a:r>
-            <a:endParaRPr lang="en-US" sz="1400" dirty="0"/>
-          </a:p>
-        </p:txBody>
-      </p:sp>
-      <p:sp>
-        <p:nvSpPr>
-          <p:cNvPr id="23" name="Text 21"/>
-          <p:cNvSpPr/>
-          <p:nvPr/>
-        </p:nvSpPr>
-        <p:spPr>
-          <a:xfrm>
-            <a:off x="1234440" y="3566160"/>
-            <a:ext cx="6949440" cy="438912"/>
-          </a:xfrm>
-          <a:prstGeom prst="rect">
-            <a:avLst/>
-          </a:prstGeom>
-          <a:noFill/>
-          <a:ln/>
-        </p:spPr>
-        <p:txBody>
-          <a:bodyPr wrap="square" rtlCol="0" anchor="ctr"/>
-          <a:lstStyle/>
-          <a:p>
-            <a:pPr indent="0" marL="0">
-              <a:buNone/>
-            </a:pPr>
-            <a:r>
-              <a:rPr lang="en-US" sz="1300" dirty="0">
-                <a:solidFill>
-                  <a:srgbClr val="3D3A36"/>
-                </a:solidFill>
-                <a:latin typeface="Calibri" pitchFamily="34" charset="0"/>
-                <a:ea typeface="Calibri" pitchFamily="34" charset="-122"/>
-                <a:cs typeface="Calibri" pitchFamily="34" charset="-120"/>
-              </a:rPr>
-              <a:t>Choosing and drawing the correct graph type</a:t>
-            </a:r>
-            <a:endParaRPr lang="en-US" sz="1300" dirty="0"/>
-          </a:p>
-        </p:txBody>
-      </p:sp>
-      <p:sp>
-        <p:nvSpPr>
-          <p:cNvPr id="24" name="Shape 22"/>
-          <p:cNvSpPr/>
-          <p:nvPr/>
-        </p:nvSpPr>
-        <p:spPr>
-          <a:xfrm>
-            <a:off x="731520" y="4251960"/>
-            <a:ext cx="7680960" cy="594360"/>
-          </a:xfrm>
-          <a:prstGeom prst="rect">
-            <a:avLst/>
-          </a:prstGeom>
-          <a:solidFill>
-            <a:srgbClr val="E8F5F3"/>
-          </a:solidFill>
-          <a:ln/>
-          <a:effectLst>
-            <a:outerShdw sx="100000" sy="100000" kx="0" ky="0" algn="bl" rotWithShape="0" blurRad="50800" dist="25400" dir="8100000">
-              <a:srgbClr val="000000">
-                <a:alpha val="10000"/>
-              </a:srgbClr>
-            </a:outerShdw>
-          </a:effectLst>
-        </p:spPr>
-      </p:sp>
-      <p:sp>
-        <p:nvSpPr>
-          <p:cNvPr id="25" name="Text 23"/>
-          <p:cNvSpPr/>
-          <p:nvPr/>
-        </p:nvSpPr>
-        <p:spPr>
-          <a:xfrm>
-            <a:off x="914400" y="4251960"/>
-            <a:ext cx="7315200" cy="594360"/>
-          </a:xfrm>
-          <a:prstGeom prst="rect">
-            <a:avLst/>
-          </a:prstGeom>
-          <a:noFill/>
-          <a:ln/>
-        </p:spPr>
-        <p:txBody>
-          <a:bodyPr wrap="square" rtlCol="0" anchor="ctr"/>
-          <a:lstStyle/>
-          <a:p>
-            <a:pPr indent="0" marL="0">
-              <a:buNone/>
-            </a:pPr>
-            <a:r>
-              <a:rPr lang="en-US" sz="1200" b="1" dirty="0">
-                <a:solidFill>
-                  <a:srgbClr val="2A9D8F"/>
-                </a:solidFill>
-                <a:latin typeface="Calibri" pitchFamily="34" charset="0"/>
-                <a:ea typeface="Calibri" pitchFamily="34" charset="-122"/>
-                <a:cs typeface="Calibri" pitchFamily="34" charset="-120"/>
-              </a:rPr>
-              <a:t>Key Idea: </a:t>
-            </a:r>
-            <a:pPr indent="0" marL="0">
-              <a:buNone/>
-            </a:pPr>
-            <a:r>
-              <a:rPr lang="en-US" sz="1200" i="1" dirty="0">
-                <a:solidFill>
-                  <a:srgbClr val="3D3A36"/>
-                </a:solidFill>
-                <a:latin typeface="Calibri" pitchFamily="34" charset="0"/>
-                <a:ea typeface="Calibri" pitchFamily="34" charset="-122"/>
-                <a:cs typeface="Calibri" pitchFamily="34" charset="-120"/>
-              </a:rPr>
-              <a:t>Review these topics, then test yourself with the Self-Quiz on mrzocchi.com.</a:t>
-            </a:r>
-            <a:endParaRPr lang="en-US" sz="1200" dirty="0"/>
-          </a:p>
-        </p:txBody>
-      </p:sp>
-    </p:spTree>
-  </p:cSld>
-  <p:clrMapOvr>
-    <a:masterClrMapping/>
-  </p:clrMapOvr>
-</p:sld>
-</file>
-
-<file path=ppt/slides/slide9.xml><?xml version="1.0" encoding="utf-8"?>
-<p:sld xmlns:a="http://schemas.openxmlformats.org/drawingml/2006/main" xmlns:r="http://schemas.openxmlformats.org/officeDocument/2006/relationships" xmlns:p="http://schemas.openxmlformats.org/presentationml/2006/main">
-  <p:cSld name="Slide 9">
-    <p:spTree>
-      <p:nvGrpSpPr>
-        <p:cNvPr id="1" name=""/>
-        <p:cNvGrpSpPr/>
-        <p:nvPr/>
-      </p:nvGrpSpPr>
-      <p:grpSpPr>
-        <a:xfrm>
-          <a:off x="0" y="0"/>
-          <a:ext cx="0" cy="0"/>
-          <a:chOff x="0" y="0"/>
-          <a:chExt cx="0" cy="0"/>
-        </a:xfrm>
-      </p:grpSpPr>
-      <p:sp>
-        <p:nvSpPr>
-          <p:cNvPr id="2" name="Shape 0"/>
-          <p:cNvSpPr/>
-          <p:nvPr/>
-        </p:nvSpPr>
-        <p:spPr>
-          <a:xfrm>
-            <a:off x="0" y="0"/>
-            <a:ext cx="9144000" cy="5143500"/>
-          </a:xfrm>
-          <a:prstGeom prst="rect">
-            <a:avLst/>
-          </a:prstGeom>
-          <a:solidFill>
-            <a:srgbClr val="1B2A4A"/>
-          </a:solidFill>
-          <a:ln/>
-        </p:spPr>
-      </p:sp>
-      <p:sp>
-        <p:nvSpPr>
-          <p:cNvPr id="3" name="Shape 1"/>
-          <p:cNvSpPr/>
-          <p:nvPr/>
-        </p:nvSpPr>
-        <p:spPr>
-          <a:xfrm>
-            <a:off x="0" y="4777740"/>
-            <a:ext cx="9144000" cy="365760"/>
+            <a:off x="548640" y="960120"/>
+            <a:ext cx="2286000" cy="36576"/>
           </a:xfrm>
           <a:prstGeom prst="rect">
             <a:avLst/>
@@ -3887,36 +3378,14 @@
       </p:sp>
       <p:sp>
         <p:nvSpPr>
-          <p:cNvPr id="4" name="Shape 2"/>
-          <p:cNvSpPr/>
-          <p:nvPr/>
-        </p:nvSpPr>
-        <p:spPr>
-          <a:xfrm>
-            <a:off x="-914400" y="-914400"/>
-            <a:ext cx="3657600" cy="3657600"/>
-          </a:xfrm>
-          <a:prstGeom prst="ellipse">
-            <a:avLst/>
-          </a:prstGeom>
-          <a:solidFill>
-            <a:srgbClr val="2A9D8F">
-              <a:alpha val="10000"/>
-            </a:srgbClr>
-          </a:solidFill>
-          <a:ln/>
-        </p:spPr>
-      </p:sp>
-      <p:sp>
-        <p:nvSpPr>
           <p:cNvPr id="5" name="Text 3"/>
           <p:cNvSpPr/>
           <p:nvPr/>
         </p:nvSpPr>
         <p:spPr>
           <a:xfrm>
-            <a:off x="731520" y="1463040"/>
-            <a:ext cx="7680960" cy="822960"/>
+            <a:off x="548640" y="1188720"/>
+            <a:ext cx="10058400" cy="3474720"/>
           </a:xfrm>
           <a:prstGeom prst="rect">
             <a:avLst/>
@@ -3925,102 +3394,95 @@
           <a:ln/>
         </p:spPr>
         <p:txBody>
-          <a:bodyPr wrap="square" rtlCol="0" anchor="ctr"/>
-          <a:lstStyle/>
-          <a:p>
-            <a:pPr algn="ctr" indent="0" marL="0">
-              <a:buNone/>
+          <a:bodyPr wrap="square" rtlCol="0" anchor="t"/>
+          <a:lstStyle/>
+          <a:p>
+            <a:pPr>
+              <a:lnSpc>
+                <a:spcPct val="150000"/>
+              </a:lnSpc>
+              <a:spcAft>
+                <a:spcPts val="600"/>
+              </a:spcAft>
             </a:pPr>
             <a:r>
-              <a:rPr lang="en-US" sz="3400" b="1" dirty="0">
+              <a:rPr lang="en-US" sz="1500" dirty="0">
                 <a:solidFill>
-                  <a:srgbClr val="FFFFFF"/>
+                  <a:srgbClr val="3D3A36"/>
                 </a:solidFill>
-                <a:latin typeface="Georgia" pitchFamily="34" charset="0"/>
-                <a:ea typeface="Georgia" pitchFamily="34" charset="-122"/>
-                <a:cs typeface="Georgia" pitchFamily="34" charset="-120"/>
+                <a:latin typeface="Arial" pitchFamily="34" charset="0"/>
+                <a:ea typeface="Arial" pitchFamily="34" charset="-122"/>
+                <a:cs typeface="Arial" pitchFamily="34" charset="-120"/>
               </a:rPr>
-              <a:t>Review &amp; Practise</a:t>
-            </a:r>
-            <a:endParaRPr lang="en-US" sz="3400" dirty="0"/>
-          </a:p>
-        </p:txBody>
-      </p:sp>
-      <p:sp>
-        <p:nvSpPr>
-          <p:cNvPr id="6" name="Text 4"/>
-          <p:cNvSpPr/>
-          <p:nvPr/>
-        </p:nvSpPr>
-        <p:spPr>
-          <a:xfrm>
-            <a:off x="731520" y="2468880"/>
-            <a:ext cx="7680960" cy="457200"/>
-          </a:xfrm>
-          <a:prstGeom prst="rect">
-            <a:avLst/>
-          </a:prstGeom>
-          <a:noFill/>
-          <a:ln/>
-        </p:spPr>
-        <p:txBody>
-          <a:bodyPr wrap="square" rtlCol="0" anchor="ctr"/>
-          <a:lstStyle/>
-          <a:p>
-            <a:pPr algn="ctr" indent="0" marL="0">
-              <a:buNone/>
+              <a:t>SI units: m, g, mL, °C, s, N.</a:t>
+            </a:r>
+            <a:endParaRPr lang="en-US" sz="1500" dirty="0"/>
+          </a:p>
+          <a:p>
+            <a:pPr>
+              <a:lnSpc>
+                <a:spcPct val="150000"/>
+              </a:lnSpc>
+              <a:spcAft>
+                <a:spcPts val="600"/>
+              </a:spcAft>
             </a:pPr>
             <a:r>
-              <a:rPr lang="en-US" sz="1800" dirty="0">
+              <a:rPr lang="en-US" sz="1500" dirty="0">
                 <a:solidFill>
-                  <a:srgbClr val="2A9D8F"/>
+                  <a:srgbClr val="3D3A36"/>
                 </a:solidFill>
-                <a:latin typeface="Calibri" pitchFamily="34" charset="0"/>
-                <a:ea typeface="Calibri" pitchFamily="34" charset="-122"/>
-                <a:cs typeface="Calibri" pitchFamily="34" charset="-120"/>
+                <a:latin typeface="Arial" pitchFamily="34" charset="0"/>
+                <a:ea typeface="Arial" pitchFamily="34" charset="-122"/>
+                <a:cs typeface="Arial" pitchFamily="34" charset="-120"/>
               </a:rPr>
-              <a:t>mrzocchi.com</a:t>
-            </a:r>
-            <a:endParaRPr lang="en-US" sz="1800" dirty="0"/>
-          </a:p>
-        </p:txBody>
-      </p:sp>
-      <p:sp>
-        <p:nvSpPr>
-          <p:cNvPr id="7" name="Text 5"/>
-          <p:cNvSpPr/>
-          <p:nvPr/>
-        </p:nvSpPr>
-        <p:spPr>
-          <a:xfrm>
-            <a:off x="731520" y="3108960"/>
-            <a:ext cx="7680960" cy="457200"/>
-          </a:xfrm>
-          <a:prstGeom prst="rect">
-            <a:avLst/>
-          </a:prstGeom>
-          <a:noFill/>
-          <a:ln/>
-        </p:spPr>
-        <p:txBody>
-          <a:bodyPr wrap="square" rtlCol="0" anchor="ctr"/>
-          <a:lstStyle/>
-          <a:p>
-            <a:pPr algn="ctr" indent="0" marL="0">
-              <a:buNone/>
+              <a:t>Read meniscus at eye level. Take 3 readings, find the mean.</a:t>
+            </a:r>
+            <a:endParaRPr lang="en-US" sz="1500" dirty="0"/>
+          </a:p>
+          <a:p>
+            <a:pPr>
+              <a:lnSpc>
+                <a:spcPct val="150000"/>
+              </a:lnSpc>
+              <a:spcAft>
+                <a:spcPts val="600"/>
+              </a:spcAft>
             </a:pPr>
             <a:r>
-              <a:rPr lang="en-US" sz="1300" dirty="0">
+              <a:rPr lang="en-US" sz="1500" dirty="0">
                 <a:solidFill>
-                  <a:srgbClr val="9B9690"/>
+                  <a:srgbClr val="3D3A36"/>
                 </a:solidFill>
-                <a:latin typeface="Calibri" pitchFamily="34" charset="0"/>
-                <a:ea typeface="Calibri" pitchFamily="34" charset="-122"/>
-                <a:cs typeface="Calibri" pitchFamily="34" charset="-120"/>
+                <a:latin typeface="Arial" pitchFamily="34" charset="0"/>
+                <a:ea typeface="Arial" pitchFamily="34" charset="-122"/>
+                <a:cs typeface="Arial" pitchFamily="34" charset="-120"/>
               </a:rPr>
-              <a:t>Use the Self-Quiz, Review Games, and Practice Builder to test yourself.</a:t>
-            </a:r>
-            <a:endParaRPr lang="en-US" sz="1300" dirty="0"/>
+              <a:t>Bar chart = categories. Line graph = continuous data.</a:t>
+            </a:r>
+            <a:endParaRPr lang="en-US" sz="1500" dirty="0"/>
+          </a:p>
+          <a:p>
+            <a:pPr>
+              <a:lnSpc>
+                <a:spcPct val="150000"/>
+              </a:lnSpc>
+              <a:spcAft>
+                <a:spcPts val="600"/>
+              </a:spcAft>
+            </a:pPr>
+            <a:r>
+              <a:rPr lang="en-US" sz="1500" dirty="0">
+                <a:solidFill>
+                  <a:srgbClr val="3D3A36"/>
+                </a:solidFill>
+                <a:latin typeface="Arial" pitchFamily="34" charset="0"/>
+                <a:ea typeface="Arial" pitchFamily="34" charset="-122"/>
+                <a:cs typeface="Arial" pitchFamily="34" charset="-120"/>
+              </a:rPr>
+              <a:t>SALT rules: Scale, Axes, Labels, Title.</a:t>
+            </a:r>
+            <a:endParaRPr lang="en-US" sz="1500" dirty="0"/>
           </a:p>
         </p:txBody>
       </p:sp>

</xml_diff>